<commit_message>
MVP: all four flows in V0; only Flow B coverage changes in V1; add Product role
- V0 now includes all flows A+B+C+D from day one - OTP and compliance present immediately
- V1 (WhatsApp Full) = V0 + Flow B expanded to remaining top intents; that is the only change
- Flow D: added description (guardrail layer - blocks unauthorised advice, PII, coverage commitments)
- Resources: added Product role to Notch team (requirements, backlog, acceptance criteria)
- PPTX slides 7 and 9 updated accordingly

Co-Authored-By: Claude Sonnet 4.6 <noreply@anthropic.com>
</commit_message>
<xml_diff>
--- a/Notch-Bullet-Kickoff.pptx
+++ b/Notch-Bullet-Kickoff.pptx
@@ -14602,7 +14602,7 @@
                 <a:ea typeface="Calibri" pitchFamily="34" charset="-122"/>
                 <a:cs typeface="Calibri" pitchFamily="34" charset="-120"/>
               </a:rPr>
-              <a:t>V0 = one FAQ flow (pipeline pilot). V1 (WhatsApp Full) = all flows + OTP - because customers must be identified from the first full release.</a:t>
+              <a:t>All four flows (A, B, C, D) are live in V0. The only change in V1 is Flow B coverage: one intent in V0, all remaining intents in V1.</a:t>
             </a:r>
             <a:endParaRPr lang="en-US" sz="1400" dirty="0"/>
           </a:p>
@@ -14617,11 +14617,11 @@
         <p:spPr>
           <a:xfrm>
             <a:off x="640080" y="2560320"/>
-            <a:ext cx="5120640" cy="2423160"/>
+            <a:ext cx="5120640" cy="2560320"/>
           </a:xfrm>
           <a:prstGeom prst="roundRect">
             <a:avLst>
-              <a:gd name="adj" fmla="val 3396"/>
+              <a:gd name="adj" fmla="val 3214"/>
             </a:avLst>
           </a:prstGeom>
           <a:solidFill>
@@ -14667,7 +14667,7 @@
               <a:buNone/>
             </a:pPr>
             <a:r>
-              <a:rPr lang="en-US" sz="1300" b="1" spc="100" kern="0" dirty="0">
+              <a:rPr lang="en-US" sz="1250" b="1" spc="100" kern="0" dirty="0">
                 <a:solidFill>
                   <a:srgbClr val="047857"/>
                 </a:solidFill>
@@ -14675,7 +14675,46 @@
                 <a:ea typeface="Calibri" pitchFamily="34" charset="-122"/>
                 <a:cs typeface="Calibri" pitchFamily="34" charset="-120"/>
               </a:rPr>
-              <a:t>V0 - PILOT (WHATSAPP MVP)</a:t>
+              <a:t>V0 - PILOT · ALL FOUR FLOWS</a:t>
+            </a:r>
+            <a:endParaRPr lang="en-US" sz="1250" dirty="0"/>
+          </a:p>
+        </p:txBody>
+      </p:sp>
+      <p:sp>
+        <p:nvSpPr>
+          <p:cNvPr id="9" name="Text 7"/>
+          <p:cNvSpPr/>
+          <p:nvPr/>
+        </p:nvSpPr>
+        <p:spPr>
+          <a:xfrm>
+            <a:off x="960120" y="3154680"/>
+            <a:ext cx="274320" cy="320040"/>
+          </a:xfrm>
+          <a:prstGeom prst="rect">
+            <a:avLst/>
+          </a:prstGeom>
+          <a:noFill/>
+          <a:ln/>
+        </p:spPr>
+        <p:txBody>
+          <a:bodyPr wrap="square" lIns="0" tIns="0" rIns="0" bIns="0" rtlCol="0" anchor="ctr"/>
+          <a:lstStyle/>
+          <a:p>
+            <a:pPr indent="0" marL="0">
+              <a:buNone/>
+            </a:pPr>
+            <a:r>
+              <a:rPr lang="en-US" sz="1300" b="1" dirty="0">
+                <a:solidFill>
+                  <a:srgbClr val="16A34A"/>
+                </a:solidFill>
+                <a:latin typeface="Calibri" pitchFamily="34" charset="0"/>
+                <a:ea typeface="Calibri" pitchFamily="34" charset="-122"/>
+                <a:cs typeface="Calibri" pitchFamily="34" charset="-120"/>
+              </a:rPr>
+              <a:t>✓</a:t>
             </a:r>
             <a:endParaRPr lang="en-US" sz="1300" dirty="0"/>
           </a:p>
@@ -14683,13 +14722,66 @@
       </p:sp>
       <p:sp>
         <p:nvSpPr>
-          <p:cNvPr id="9" name="Text 7"/>
-          <p:cNvSpPr/>
-          <p:nvPr/>
-        </p:nvSpPr>
-        <p:spPr>
-          <a:xfrm>
-            <a:off x="960120" y="3200400"/>
+          <p:cNvPr id="10" name="Text 8"/>
+          <p:cNvSpPr/>
+          <p:nvPr/>
+        </p:nvSpPr>
+        <p:spPr>
+          <a:xfrm>
+            <a:off x="1280160" y="3154680"/>
+            <a:ext cx="4297680" cy="384048"/>
+          </a:xfrm>
+          <a:prstGeom prst="rect">
+            <a:avLst/>
+          </a:prstGeom>
+          <a:noFill/>
+          <a:ln/>
+        </p:spPr>
+        <p:txBody>
+          <a:bodyPr wrap="square" lIns="0" tIns="0" rIns="0" bIns="0" rtlCol="0" anchor="ctr"/>
+          <a:lstStyle/>
+          <a:p>
+            <a:pPr indent="0" marL="0">
+              <a:buNone/>
+            </a:pPr>
+            <a:r>
+              <a:rPr lang="en-US" sz="1200" b="1" dirty="0">
+                <a:solidFill>
+                  <a:srgbClr val="111827"/>
+                </a:solidFill>
+                <a:latin typeface="Calibri" pitchFamily="34" charset="0"/>
+                <a:ea typeface="Calibri" pitchFamily="34" charset="-122"/>
+                <a:cs typeface="Calibri" pitchFamily="34" charset="-120"/>
+              </a:rPr>
+              <a:t>Flow A </a:t>
+            </a:r>
+            <a:pPr indent="0" marL="0">
+              <a:buNone/>
+            </a:pPr>
+            <a:r>
+              <a:rPr lang="en-US" sz="1200" dirty="0">
+                <a:solidFill>
+                  <a:srgbClr val="374151"/>
+                </a:solidFill>
+                <a:latin typeface="Calibri" pitchFamily="34" charset="0"/>
+                <a:ea typeface="Calibri" pitchFamily="34" charset="-122"/>
+                <a:cs typeface="Calibri" pitchFamily="34" charset="-120"/>
+              </a:rPr>
+              <a:t>- Routing &amp; Handoff - IVR + Glassix fallback</a:t>
+            </a:r>
+            <a:endParaRPr lang="en-US" sz="1200" dirty="0"/>
+          </a:p>
+        </p:txBody>
+      </p:sp>
+      <p:sp>
+        <p:nvSpPr>
+          <p:cNvPr id="11" name="Text 9"/>
+          <p:cNvSpPr/>
+          <p:nvPr/>
+        </p:nvSpPr>
+        <p:spPr>
+          <a:xfrm>
+            <a:off x="960120" y="3611880"/>
             <a:ext cx="274320" cy="320040"/>
           </a:xfrm>
           <a:prstGeom prst="rect">
@@ -14706,7 +14798,7 @@
               <a:buNone/>
             </a:pPr>
             <a:r>
-              <a:rPr lang="en-US" sz="1400" b="1" dirty="0">
+              <a:rPr lang="en-US" sz="1300" b="1" dirty="0">
                 <a:solidFill>
                   <a:srgbClr val="16A34A"/>
                 </a:solidFill>
@@ -14716,36 +14808,36 @@
               </a:rPr>
               <a:t>✓</a:t>
             </a:r>
-            <a:endParaRPr lang="en-US" sz="1400" dirty="0"/>
-          </a:p>
-        </p:txBody>
-      </p:sp>
-      <p:sp>
-        <p:nvSpPr>
-          <p:cNvPr id="10" name="Text 8"/>
-          <p:cNvSpPr/>
-          <p:nvPr/>
-        </p:nvSpPr>
-        <p:spPr>
-          <a:xfrm>
-            <a:off x="1280160" y="3200400"/>
-            <a:ext cx="4297680" cy="411480"/>
-          </a:xfrm>
-          <a:prstGeom prst="rect">
-            <a:avLst/>
-          </a:prstGeom>
-          <a:noFill/>
-          <a:ln/>
-        </p:spPr>
-        <p:txBody>
-          <a:bodyPr wrap="square" lIns="0" tIns="0" rIns="0" bIns="0" rtlCol="0" anchor="ctr"/>
-          <a:lstStyle/>
-          <a:p>
-            <a:pPr indent="0" marL="0">
-              <a:buNone/>
-            </a:pPr>
-            <a:r>
-              <a:rPr lang="en-US" sz="1250" b="1" dirty="0">
+            <a:endParaRPr lang="en-US" sz="1300" dirty="0"/>
+          </a:p>
+        </p:txBody>
+      </p:sp>
+      <p:sp>
+        <p:nvSpPr>
+          <p:cNvPr id="12" name="Text 10"/>
+          <p:cNvSpPr/>
+          <p:nvPr/>
+        </p:nvSpPr>
+        <p:spPr>
+          <a:xfrm>
+            <a:off x="1280160" y="3611880"/>
+            <a:ext cx="4297680" cy="384048"/>
+          </a:xfrm>
+          <a:prstGeom prst="rect">
+            <a:avLst/>
+          </a:prstGeom>
+          <a:noFill/>
+          <a:ln/>
+        </p:spPr>
+        <p:txBody>
+          <a:bodyPr wrap="square" lIns="0" tIns="0" rIns="0" bIns="0" rtlCol="0" anchor="ctr"/>
+          <a:lstStyle/>
+          <a:p>
+            <a:pPr indent="0" marL="0">
+              <a:buNone/>
+            </a:pPr>
+            <a:r>
+              <a:rPr lang="en-US" sz="1200" b="1" dirty="0">
                 <a:solidFill>
                   <a:srgbClr val="111827"/>
                 </a:solidFill>
@@ -14753,13 +14845,13 @@
                 <a:ea typeface="Calibri" pitchFamily="34" charset="-122"/>
                 <a:cs typeface="Calibri" pitchFamily="34" charset="-120"/>
               </a:rPr>
-              <a:t>Flow A </a:t>
-            </a:r>
-            <a:pPr indent="0" marL="0">
-              <a:buNone/>
-            </a:pPr>
-            <a:r>
-              <a:rPr lang="en-US" sz="1250" dirty="0">
+              <a:t>Flow B </a:t>
+            </a:r>
+            <a:pPr indent="0" marL="0">
+              <a:buNone/>
+            </a:pPr>
+            <a:r>
+              <a:rPr lang="en-US" sz="1200" dirty="0">
                 <a:solidFill>
                   <a:srgbClr val="374151"/>
                 </a:solidFill>
@@ -14767,21 +14859,21 @@
                 <a:ea typeface="Calibri" pitchFamily="34" charset="-122"/>
                 <a:cs typeface="Calibri" pitchFamily="34" charset="-120"/>
               </a:rPr>
-              <a:t>- Routing &amp; Handoff - IVR replace + Glassix</a:t>
-            </a:r>
-            <a:endParaRPr lang="en-US" sz="1250" dirty="0"/>
-          </a:p>
-        </p:txBody>
-      </p:sp>
-      <p:sp>
-        <p:nvSpPr>
-          <p:cNvPr id="11" name="Text 9"/>
-          <p:cNvSpPr/>
-          <p:nvPr/>
-        </p:nvSpPr>
-        <p:spPr>
-          <a:xfrm>
-            <a:off x="960120" y="3703320"/>
+              <a:t>- ONE intent only - proves pipeline, first containment</a:t>
+            </a:r>
+            <a:endParaRPr lang="en-US" sz="1200" dirty="0"/>
+          </a:p>
+        </p:txBody>
+      </p:sp>
+      <p:sp>
+        <p:nvSpPr>
+          <p:cNvPr id="13" name="Text 11"/>
+          <p:cNvSpPr/>
+          <p:nvPr/>
+        </p:nvSpPr>
+        <p:spPr>
+          <a:xfrm>
+            <a:off x="960120" y="4069080"/>
             <a:ext cx="274320" cy="320040"/>
           </a:xfrm>
           <a:prstGeom prst="rect">
@@ -14798,7 +14890,7 @@
               <a:buNone/>
             </a:pPr>
             <a:r>
-              <a:rPr lang="en-US" sz="1400" b="1" dirty="0">
+              <a:rPr lang="en-US" sz="1300" b="1" dirty="0">
                 <a:solidFill>
                   <a:srgbClr val="16A34A"/>
                 </a:solidFill>
@@ -14808,36 +14900,36 @@
               </a:rPr>
               <a:t>✓</a:t>
             </a:r>
-            <a:endParaRPr lang="en-US" sz="1400" dirty="0"/>
-          </a:p>
-        </p:txBody>
-      </p:sp>
-      <p:sp>
-        <p:nvSpPr>
-          <p:cNvPr id="12" name="Text 10"/>
-          <p:cNvSpPr/>
-          <p:nvPr/>
-        </p:nvSpPr>
-        <p:spPr>
-          <a:xfrm>
-            <a:off x="1280160" y="3703320"/>
-            <a:ext cx="4297680" cy="411480"/>
-          </a:xfrm>
-          <a:prstGeom prst="rect">
-            <a:avLst/>
-          </a:prstGeom>
-          <a:noFill/>
-          <a:ln/>
-        </p:spPr>
-        <p:txBody>
-          <a:bodyPr wrap="square" lIns="0" tIns="0" rIns="0" bIns="0" rtlCol="0" anchor="ctr"/>
-          <a:lstStyle/>
-          <a:p>
-            <a:pPr indent="0" marL="0">
-              <a:buNone/>
-            </a:pPr>
-            <a:r>
-              <a:rPr lang="en-US" sz="1250" b="1" dirty="0">
+            <a:endParaRPr lang="en-US" sz="1300" dirty="0"/>
+          </a:p>
+        </p:txBody>
+      </p:sp>
+      <p:sp>
+        <p:nvSpPr>
+          <p:cNvPr id="14" name="Text 12"/>
+          <p:cNvSpPr/>
+          <p:nvPr/>
+        </p:nvSpPr>
+        <p:spPr>
+          <a:xfrm>
+            <a:off x="1280160" y="4069080"/>
+            <a:ext cx="4297680" cy="384048"/>
+          </a:xfrm>
+          <a:prstGeom prst="rect">
+            <a:avLst/>
+          </a:prstGeom>
+          <a:noFill/>
+          <a:ln/>
+        </p:spPr>
+        <p:txBody>
+          <a:bodyPr wrap="square" lIns="0" tIns="0" rIns="0" bIns="0" rtlCol="0" anchor="ctr"/>
+          <a:lstStyle/>
+          <a:p>
+            <a:pPr indent="0" marL="0">
+              <a:buNone/>
+            </a:pPr>
+            <a:r>
+              <a:rPr lang="en-US" sz="1200" b="1" dirty="0">
                 <a:solidFill>
                   <a:srgbClr val="111827"/>
                 </a:solidFill>
@@ -14845,13 +14937,13 @@
                 <a:ea typeface="Calibri" pitchFamily="34" charset="-122"/>
                 <a:cs typeface="Calibri" pitchFamily="34" charset="-120"/>
               </a:rPr>
-              <a:t>Flow B </a:t>
-            </a:r>
-            <a:pPr indent="0" marL="0">
-              <a:buNone/>
-            </a:pPr>
-            <a:r>
-              <a:rPr lang="en-US" sz="1250" dirty="0">
+              <a:t>Flow C </a:t>
+            </a:r>
+            <a:pPr indent="0" marL="0">
+              <a:buNone/>
+            </a:pPr>
+            <a:r>
+              <a:rPr lang="en-US" sz="1200" dirty="0">
                 <a:solidFill>
                   <a:srgbClr val="374151"/>
                 </a:solidFill>
@@ -14859,21 +14951,21 @@
                 <a:ea typeface="Calibri" pitchFamily="34" charset="-122"/>
                 <a:cs typeface="Calibri" pitchFamily="34" charset="-120"/>
               </a:rPr>
-              <a:t>- ONE intent - proves pipeline, first containment</a:t>
-            </a:r>
-            <a:endParaRPr lang="en-US" sz="1250" dirty="0"/>
-          </a:p>
-        </p:txBody>
-      </p:sp>
-      <p:sp>
-        <p:nvSpPr>
-          <p:cNvPr id="13" name="Text 11"/>
-          <p:cNvSpPr/>
-          <p:nvPr/>
-        </p:nvSpPr>
-        <p:spPr>
-          <a:xfrm>
-            <a:off x="960120" y="4206240"/>
+              <a:t>- OTP + identity - customer identified from day one</a:t>
+            </a:r>
+            <a:endParaRPr lang="en-US" sz="1200" dirty="0"/>
+          </a:p>
+        </p:txBody>
+      </p:sp>
+      <p:sp>
+        <p:nvSpPr>
+          <p:cNvPr id="15" name="Text 13"/>
+          <p:cNvSpPr/>
+          <p:nvPr/>
+        </p:nvSpPr>
+        <p:spPr>
+          <a:xfrm>
+            <a:off x="960120" y="4526280"/>
             <a:ext cx="274320" cy="320040"/>
           </a:xfrm>
           <a:prstGeom prst="rect">
@@ -14890,7 +14982,7 @@
               <a:buNone/>
             </a:pPr>
             <a:r>
-              <a:rPr lang="en-US" sz="1400" b="1" dirty="0">
+              <a:rPr lang="en-US" sz="1300" b="1" dirty="0">
                 <a:solidFill>
                   <a:srgbClr val="16A34A"/>
                 </a:solidFill>
@@ -14900,36 +14992,36 @@
               </a:rPr>
               <a:t>✓</a:t>
             </a:r>
-            <a:endParaRPr lang="en-US" sz="1400" dirty="0"/>
-          </a:p>
-        </p:txBody>
-      </p:sp>
-      <p:sp>
-        <p:nvSpPr>
-          <p:cNvPr id="14" name="Text 12"/>
-          <p:cNvSpPr/>
-          <p:nvPr/>
-        </p:nvSpPr>
-        <p:spPr>
-          <a:xfrm>
-            <a:off x="1280160" y="4206240"/>
-            <a:ext cx="4297680" cy="411480"/>
-          </a:xfrm>
-          <a:prstGeom prst="rect">
-            <a:avLst/>
-          </a:prstGeom>
-          <a:noFill/>
-          <a:ln/>
-        </p:spPr>
-        <p:txBody>
-          <a:bodyPr wrap="square" lIns="0" tIns="0" rIns="0" bIns="0" rtlCol="0" anchor="ctr"/>
-          <a:lstStyle/>
-          <a:p>
-            <a:pPr indent="0" marL="0">
-              <a:buNone/>
-            </a:pPr>
-            <a:r>
-              <a:rPr lang="en-US" sz="1250" b="1" dirty="0">
+            <a:endParaRPr lang="en-US" sz="1300" dirty="0"/>
+          </a:p>
+        </p:txBody>
+      </p:sp>
+      <p:sp>
+        <p:nvSpPr>
+          <p:cNvPr id="16" name="Text 14"/>
+          <p:cNvSpPr/>
+          <p:nvPr/>
+        </p:nvSpPr>
+        <p:spPr>
+          <a:xfrm>
+            <a:off x="1280160" y="4526280"/>
+            <a:ext cx="4297680" cy="384048"/>
+          </a:xfrm>
+          <a:prstGeom prst="rect">
+            <a:avLst/>
+          </a:prstGeom>
+          <a:noFill/>
+          <a:ln/>
+        </p:spPr>
+        <p:txBody>
+          <a:bodyPr wrap="square" lIns="0" tIns="0" rIns="0" bIns="0" rtlCol="0" anchor="ctr"/>
+          <a:lstStyle/>
+          <a:p>
+            <a:pPr indent="0" marL="0">
+              <a:buNone/>
+            </a:pPr>
+            <a:r>
+              <a:rPr lang="en-US" sz="1200" b="1" dirty="0">
                 <a:solidFill>
                   <a:srgbClr val="111827"/>
                 </a:solidFill>
@@ -14943,7 +15035,7 @@
               <a:buNone/>
             </a:pPr>
             <a:r>
-              <a:rPr lang="en-US" sz="1250" dirty="0">
+              <a:rPr lang="en-US" sz="1200" dirty="0">
                 <a:solidFill>
                   <a:srgbClr val="374151"/>
                 </a:solidFill>
@@ -14951,65 +15043,26 @@
                 <a:ea typeface="Calibri" pitchFamily="34" charset="-122"/>
                 <a:cs typeface="Calibri" pitchFamily="34" charset="-120"/>
               </a:rPr>
-              <a:t>- Guardrail baseline - minimum compliance gate</a:t>
-            </a:r>
-            <a:endParaRPr lang="en-US" sz="1250" dirty="0"/>
-          </a:p>
-        </p:txBody>
-      </p:sp>
-      <p:sp>
-        <p:nvSpPr>
-          <p:cNvPr id="15" name="Text 13"/>
-          <p:cNvSpPr/>
-          <p:nvPr/>
-        </p:nvSpPr>
-        <p:spPr>
-          <a:xfrm>
-            <a:off x="960120" y="4663440"/>
-            <a:ext cx="4572000" cy="274320"/>
-          </a:xfrm>
-          <a:prstGeom prst="rect">
-            <a:avLst/>
-          </a:prstGeom>
-          <a:noFill/>
-          <a:ln/>
-        </p:spPr>
-        <p:txBody>
-          <a:bodyPr wrap="square" lIns="0" tIns="0" rIns="0" bIns="0" rtlCol="0" anchor="ctr"/>
-          <a:lstStyle/>
-          <a:p>
-            <a:pPr indent="0" marL="0">
-              <a:buNone/>
-            </a:pPr>
-            <a:r>
-              <a:rPr lang="en-US" sz="1100" i="1" dirty="0">
-                <a:solidFill>
-                  <a:srgbClr val="047857"/>
-                </a:solidFill>
-                <a:latin typeface="Calibri" pitchFamily="34" charset="0"/>
-                <a:ea typeface="Calibri" pitchFamily="34" charset="-122"/>
-                <a:cs typeface="Calibri" pitchFamily="34" charset="-120"/>
-              </a:rPr>
-              <a:t>Then V1 (WhatsApp Full): all flows A+B+C+D including OTP identity verification.</a:t>
-            </a:r>
-            <a:endParaRPr lang="en-US" sz="1100" dirty="0"/>
-          </a:p>
-        </p:txBody>
-      </p:sp>
-      <p:sp>
-        <p:nvSpPr>
-          <p:cNvPr id="16" name="Shape 14"/>
+              <a:t>- Safety &amp; Compliance baseline - always on</a:t>
+            </a:r>
+            <a:endParaRPr lang="en-US" sz="1200" dirty="0"/>
+          </a:p>
+        </p:txBody>
+      </p:sp>
+      <p:sp>
+        <p:nvSpPr>
+          <p:cNvPr id="17" name="Shape 15"/>
           <p:cNvSpPr/>
           <p:nvPr/>
         </p:nvSpPr>
         <p:spPr>
           <a:xfrm>
             <a:off x="6035040" y="2560320"/>
-            <a:ext cx="5120640" cy="2423160"/>
+            <a:ext cx="5120640" cy="2560320"/>
           </a:xfrm>
           <a:prstGeom prst="roundRect">
             <a:avLst>
-              <a:gd name="adj" fmla="val 3396"/>
+              <a:gd name="adj" fmla="val 3214"/>
             </a:avLst>
           </a:prstGeom>
           <a:solidFill>
@@ -15025,7 +15078,7 @@
       </p:sp>
       <p:sp>
         <p:nvSpPr>
-          <p:cNvPr id="17" name="Text 15"/>
+          <p:cNvPr id="18" name="Text 16"/>
           <p:cNvSpPr/>
           <p:nvPr/>
         </p:nvSpPr>
@@ -15048,7 +15101,7 @@
               <a:buNone/>
             </a:pPr>
             <a:r>
-              <a:rPr lang="en-US" sz="1300" b="1" spc="100" kern="0" dirty="0">
+              <a:rPr lang="en-US" sz="1250" b="1" spc="100" kern="0" dirty="0">
                 <a:solidFill>
                   <a:srgbClr val="6B7280"/>
                 </a:solidFill>
@@ -15056,38 +15109,116 @@
                 <a:ea typeface="Calibri" pitchFamily="34" charset="-122"/>
                 <a:cs typeface="Calibri" pitchFamily="34" charset="-120"/>
               </a:rPr>
+              <a:t>V1 - WHATSAPP FULL</a:t>
+            </a:r>
+            <a:endParaRPr lang="en-US" sz="1250" dirty="0"/>
+          </a:p>
+        </p:txBody>
+      </p:sp>
+      <p:sp>
+        <p:nvSpPr>
+          <p:cNvPr id="19" name="Text 17"/>
+          <p:cNvSpPr/>
+          <p:nvPr/>
+        </p:nvSpPr>
+        <p:spPr>
+          <a:xfrm>
+            <a:off x="6355080" y="3108960"/>
+            <a:ext cx="4572000" cy="457200"/>
+          </a:xfrm>
+          <a:prstGeom prst="rect">
+            <a:avLst/>
+          </a:prstGeom>
+          <a:noFill/>
+          <a:ln/>
+        </p:spPr>
+        <p:txBody>
+          <a:bodyPr wrap="square" lIns="0" tIns="0" rIns="0" bIns="0" rtlCol="0" anchor="ctr"/>
+          <a:lstStyle/>
+          <a:p>
+            <a:pPr indent="0" marL="0">
+              <a:buNone/>
+            </a:pPr>
+            <a:r>
+              <a:rPr lang="en-US" sz="1200" dirty="0">
+                <a:solidFill>
+                  <a:srgbClr val="374151"/>
+                </a:solidFill>
+                <a:latin typeface="Calibri" pitchFamily="34" charset="0"/>
+                <a:ea typeface="Calibri" pitchFamily="34" charset="-122"/>
+                <a:cs typeface="Calibri" pitchFamily="34" charset="-120"/>
+              </a:rPr>
+              <a:t>= V0 unchanged + Flow B expanded (all remaining top intents). This is the only difference.</a:t>
+            </a:r>
+            <a:endParaRPr lang="en-US" sz="1200" dirty="0"/>
+          </a:p>
+        </p:txBody>
+      </p:sp>
+      <p:sp>
+        <p:nvSpPr>
+          <p:cNvPr id="20" name="Text 18"/>
+          <p:cNvSpPr/>
+          <p:nvPr/>
+        </p:nvSpPr>
+        <p:spPr>
+          <a:xfrm>
+            <a:off x="6355080" y="3703320"/>
+            <a:ext cx="4572000" cy="274320"/>
+          </a:xfrm>
+          <a:prstGeom prst="rect">
+            <a:avLst/>
+          </a:prstGeom>
+          <a:noFill/>
+          <a:ln/>
+        </p:spPr>
+        <p:txBody>
+          <a:bodyPr wrap="square" lIns="0" tIns="0" rIns="0" bIns="0" rtlCol="0" anchor="ctr"/>
+          <a:lstStyle/>
+          <a:p>
+            <a:pPr indent="0" marL="0">
+              <a:buNone/>
+            </a:pPr>
+            <a:r>
+              <a:rPr lang="en-US" sz="1250" b="1" spc="100" kern="0" dirty="0">
+                <a:solidFill>
+                  <a:srgbClr val="6B7280"/>
+                </a:solidFill>
+                <a:latin typeface="Calibri" pitchFamily="34" charset="0"/>
+                <a:ea typeface="Calibri" pitchFamily="34" charset="-122"/>
+                <a:cs typeface="Calibri" pitchFamily="34" charset="-120"/>
+              </a:rPr>
               <a:t>V2 - WHATSAPP COMPLETE</a:t>
             </a:r>
-            <a:endParaRPr lang="en-US" sz="1300" dirty="0"/>
-          </a:p>
-        </p:txBody>
-      </p:sp>
-      <p:sp>
-        <p:nvSpPr>
-          <p:cNvPr id="18" name="Text 16"/>
-          <p:cNvSpPr/>
-          <p:nvPr/>
-        </p:nvSpPr>
-        <p:spPr>
-          <a:xfrm>
-            <a:off x="6355080" y="3200400"/>
-            <a:ext cx="1371600" cy="411480"/>
-          </a:xfrm>
-          <a:prstGeom prst="rect">
-            <a:avLst/>
-          </a:prstGeom>
-          <a:noFill/>
-          <a:ln/>
-        </p:spPr>
-        <p:txBody>
-          <a:bodyPr wrap="square" lIns="0" tIns="0" rIns="0" bIns="0" rtlCol="0" anchor="ctr"/>
-          <a:lstStyle/>
-          <a:p>
-            <a:pPr indent="0" marL="0">
-              <a:buNone/>
-            </a:pPr>
-            <a:r>
-              <a:rPr lang="en-US" sz="1250" b="1" dirty="0">
+            <a:endParaRPr lang="en-US" sz="1250" dirty="0"/>
+          </a:p>
+        </p:txBody>
+      </p:sp>
+      <p:sp>
+        <p:nvSpPr>
+          <p:cNvPr id="21" name="Text 19"/>
+          <p:cNvSpPr/>
+          <p:nvPr/>
+        </p:nvSpPr>
+        <p:spPr>
+          <a:xfrm>
+            <a:off x="6355080" y="4023360"/>
+            <a:ext cx="4572000" cy="347472"/>
+          </a:xfrm>
+          <a:prstGeom prst="rect">
+            <a:avLst/>
+          </a:prstGeom>
+          <a:noFill/>
+          <a:ln/>
+        </p:spPr>
+        <p:txBody>
+          <a:bodyPr wrap="square" lIns="0" tIns="0" rIns="0" bIns="0" rtlCol="0" anchor="ctr"/>
+          <a:lstStyle/>
+          <a:p>
+            <a:pPr indent="0" marL="0">
+              <a:buNone/>
+            </a:pPr>
+            <a:r>
+              <a:rPr lang="en-US" sz="1200" b="1" dirty="0">
                 <a:solidFill>
                   <a:srgbClr val="111827"/>
                 </a:solidFill>
@@ -15095,38 +15226,13 @@
                 <a:ea typeface="Calibri" pitchFamily="34" charset="-122"/>
                 <a:cs typeface="Calibri" pitchFamily="34" charset="-120"/>
               </a:rPr>
-              <a:t>Full KB:</a:t>
-            </a:r>
-            <a:endParaRPr lang="en-US" sz="1250" dirty="0"/>
-          </a:p>
-        </p:txBody>
-      </p:sp>
-      <p:sp>
-        <p:nvSpPr>
-          <p:cNvPr id="19" name="Text 17"/>
-          <p:cNvSpPr/>
-          <p:nvPr/>
-        </p:nvSpPr>
-        <p:spPr>
-          <a:xfrm>
-            <a:off x="7726680" y="3200400"/>
-            <a:ext cx="3474720" cy="411480"/>
-          </a:xfrm>
-          <a:prstGeom prst="rect">
-            <a:avLst/>
-          </a:prstGeom>
-          <a:noFill/>
-          <a:ln/>
-        </p:spPr>
-        <p:txBody>
-          <a:bodyPr wrap="square" lIns="0" tIns="0" rIns="0" bIns="0" rtlCol="0" anchor="ctr"/>
-          <a:lstStyle/>
-          <a:p>
-            <a:pPr indent="0" marL="0">
-              <a:buNone/>
-            </a:pPr>
-            <a:r>
-              <a:rPr lang="en-US" sz="1250" dirty="0">
+              <a:t>Full KB: </a:t>
+            </a:r>
+            <a:pPr indent="0" marL="0">
+              <a:buNone/>
+            </a:pPr>
+            <a:r>
+              <a:rPr lang="en-US" sz="1200" dirty="0">
                 <a:solidFill>
                   <a:srgbClr val="374151"/>
                 </a:solidFill>
@@ -15134,38 +15240,38 @@
                 <a:ea typeface="Calibri" pitchFamily="34" charset="-122"/>
                 <a:cs typeface="Calibri" pitchFamily="34" charset="-120"/>
               </a:rPr>
-              <a:t>all intents indexed, not just top-N</a:t>
-            </a:r>
-            <a:endParaRPr lang="en-US" sz="1250" dirty="0"/>
-          </a:p>
-        </p:txBody>
-      </p:sp>
-      <p:sp>
-        <p:nvSpPr>
-          <p:cNvPr id="20" name="Text 18"/>
-          <p:cNvSpPr/>
-          <p:nvPr/>
-        </p:nvSpPr>
-        <p:spPr>
-          <a:xfrm>
-            <a:off x="6355080" y="3703320"/>
-            <a:ext cx="1371600" cy="411480"/>
-          </a:xfrm>
-          <a:prstGeom prst="rect">
-            <a:avLst/>
-          </a:prstGeom>
-          <a:noFill/>
-          <a:ln/>
-        </p:spPr>
-        <p:txBody>
-          <a:bodyPr wrap="square" lIns="0" tIns="0" rIns="0" bIns="0" rtlCol="0" anchor="ctr"/>
-          <a:lstStyle/>
-          <a:p>
-            <a:pPr indent="0" marL="0">
-              <a:buNone/>
-            </a:pPr>
-            <a:r>
-              <a:rPr lang="en-US" sz="1250" b="1" dirty="0">
+              <a:t>all intents, not just top-N</a:t>
+            </a:r>
+            <a:endParaRPr lang="en-US" sz="1200" dirty="0"/>
+          </a:p>
+        </p:txBody>
+      </p:sp>
+      <p:sp>
+        <p:nvSpPr>
+          <p:cNvPr id="22" name="Text 20"/>
+          <p:cNvSpPr/>
+          <p:nvPr/>
+        </p:nvSpPr>
+        <p:spPr>
+          <a:xfrm>
+            <a:off x="6355080" y="4416552"/>
+            <a:ext cx="4572000" cy="347472"/>
+          </a:xfrm>
+          <a:prstGeom prst="rect">
+            <a:avLst/>
+          </a:prstGeom>
+          <a:noFill/>
+          <a:ln/>
+        </p:spPr>
+        <p:txBody>
+          <a:bodyPr wrap="square" lIns="0" tIns="0" rIns="0" bIns="0" rtlCol="0" anchor="ctr"/>
+          <a:lstStyle/>
+          <a:p>
+            <a:pPr indent="0" marL="0">
+              <a:buNone/>
+            </a:pPr>
+            <a:r>
+              <a:rPr lang="en-US" sz="1200" b="1" dirty="0">
                 <a:solidFill>
                   <a:srgbClr val="111827"/>
                 </a:solidFill>
@@ -15173,38 +15279,13 @@
                 <a:ea typeface="Calibri" pitchFamily="34" charset="-122"/>
                 <a:cs typeface="Calibri" pitchFamily="34" charset="-120"/>
               </a:rPr>
-              <a:t>Prompt hardening:</a:t>
-            </a:r>
-            <a:endParaRPr lang="en-US" sz="1250" dirty="0"/>
-          </a:p>
-        </p:txBody>
-      </p:sp>
-      <p:sp>
-        <p:nvSpPr>
-          <p:cNvPr id="21" name="Text 19"/>
-          <p:cNvSpPr/>
-          <p:nvPr/>
-        </p:nvSpPr>
-        <p:spPr>
-          <a:xfrm>
-            <a:off x="7726680" y="3703320"/>
-            <a:ext cx="3474720" cy="411480"/>
-          </a:xfrm>
-          <a:prstGeom prst="rect">
-            <a:avLst/>
-          </a:prstGeom>
-          <a:noFill/>
-          <a:ln/>
-        </p:spPr>
-        <p:txBody>
-          <a:bodyPr wrap="square" lIns="0" tIns="0" rIns="0" bIns="0" rtlCol="0" anchor="ctr"/>
-          <a:lstStyle/>
-          <a:p>
-            <a:pPr indent="0" marL="0">
-              <a:buNone/>
-            </a:pPr>
-            <a:r>
-              <a:rPr lang="en-US" sz="1250" dirty="0">
+              <a:t>Hardening: </a:t>
+            </a:r>
+            <a:pPr indent="0" marL="0">
+              <a:buNone/>
+            </a:pPr>
+            <a:r>
+              <a:rPr lang="en-US" sz="1200" dirty="0">
                 <a:solidFill>
                   <a:srgbClr val="374151"/>
                 </a:solidFill>
@@ -15212,38 +15293,38 @@
                 <a:ea typeface="Calibri" pitchFamily="34" charset="-122"/>
                 <a:cs typeface="Calibri" pitchFamily="34" charset="-120"/>
               </a:rPr>
-              <a:t>adversarial + injection testing</a:t>
-            </a:r>
-            <a:endParaRPr lang="en-US" sz="1250" dirty="0"/>
-          </a:p>
-        </p:txBody>
-      </p:sp>
-      <p:sp>
-        <p:nvSpPr>
-          <p:cNvPr id="22" name="Text 20"/>
-          <p:cNvSpPr/>
-          <p:nvPr/>
-        </p:nvSpPr>
-        <p:spPr>
-          <a:xfrm>
-            <a:off x="6355080" y="4206240"/>
-            <a:ext cx="1371600" cy="411480"/>
-          </a:xfrm>
-          <a:prstGeom prst="rect">
-            <a:avLst/>
-          </a:prstGeom>
-          <a:noFill/>
-          <a:ln/>
-        </p:spPr>
-        <p:txBody>
-          <a:bodyPr wrap="square" lIns="0" tIns="0" rIns="0" bIns="0" rtlCol="0" anchor="ctr"/>
-          <a:lstStyle/>
-          <a:p>
-            <a:pPr indent="0" marL="0">
-              <a:buNone/>
-            </a:pPr>
-            <a:r>
-              <a:rPr lang="en-US" sz="1250" b="1" dirty="0">
+              <a:t>adversarial + prompt injection</a:t>
+            </a:r>
+            <a:endParaRPr lang="en-US" sz="1200" dirty="0"/>
+          </a:p>
+        </p:txBody>
+      </p:sp>
+      <p:sp>
+        <p:nvSpPr>
+          <p:cNvPr id="23" name="Text 21"/>
+          <p:cNvSpPr/>
+          <p:nvPr/>
+        </p:nvSpPr>
+        <p:spPr>
+          <a:xfrm>
+            <a:off x="6355080" y="4809744"/>
+            <a:ext cx="4572000" cy="347472"/>
+          </a:xfrm>
+          <a:prstGeom prst="rect">
+            <a:avLst/>
+          </a:prstGeom>
+          <a:noFill/>
+          <a:ln/>
+        </p:spPr>
+        <p:txBody>
+          <a:bodyPr wrap="square" lIns="0" tIns="0" rIns="0" bIns="0" rtlCol="0" anchor="ctr"/>
+          <a:lstStyle/>
+          <a:p>
+            <a:pPr indent="0" marL="0">
+              <a:buNone/>
+            </a:pPr>
+            <a:r>
+              <a:rPr lang="en-US" sz="1200" b="1" dirty="0">
                 <a:solidFill>
                   <a:srgbClr val="111827"/>
                 </a:solidFill>
@@ -15251,38 +15332,13 @@
                 <a:ea typeface="Calibri" pitchFamily="34" charset="-122"/>
                 <a:cs typeface="Calibri" pitchFamily="34" charset="-120"/>
               </a:rPr>
-              <a:t>Website scraping:</a:t>
-            </a:r>
-            <a:endParaRPr lang="en-US" sz="1250" dirty="0"/>
-          </a:p>
-        </p:txBody>
-      </p:sp>
-      <p:sp>
-        <p:nvSpPr>
-          <p:cNvPr id="23" name="Text 21"/>
-          <p:cNvSpPr/>
-          <p:nvPr/>
-        </p:nvSpPr>
-        <p:spPr>
-          <a:xfrm>
-            <a:off x="7726680" y="4206240"/>
-            <a:ext cx="3474720" cy="411480"/>
-          </a:xfrm>
-          <a:prstGeom prst="rect">
-            <a:avLst/>
-          </a:prstGeom>
-          <a:noFill/>
-          <a:ln/>
-        </p:spPr>
-        <p:txBody>
-          <a:bodyPr wrap="square" lIns="0" tIns="0" rIns="0" bIns="0" rtlCol="0" anchor="ctr"/>
-          <a:lstStyle/>
-          <a:p>
-            <a:pPr indent="0" marL="0">
-              <a:buNone/>
-            </a:pPr>
-            <a:r>
-              <a:rPr lang="en-US" sz="1250" dirty="0">
+              <a:t>Scraping: </a:t>
+            </a:r>
+            <a:pPr indent="0" marL="0">
+              <a:buNone/>
+            </a:pPr>
+            <a:r>
+              <a:rPr lang="en-US" sz="1200" dirty="0">
                 <a:solidFill>
                   <a:srgbClr val="374151"/>
                 </a:solidFill>
@@ -15292,52 +15348,13 @@
               </a:rPr>
               <a:t>Bullet's web content auto-indexed</a:t>
             </a:r>
-            <a:endParaRPr lang="en-US" sz="1250" dirty="0"/>
+            <a:endParaRPr lang="en-US" sz="1200" dirty="0"/>
           </a:p>
         </p:txBody>
       </p:sp>
       <p:sp>
         <p:nvSpPr>
           <p:cNvPr id="24" name="Text 22"/>
-          <p:cNvSpPr/>
-          <p:nvPr/>
-        </p:nvSpPr>
-        <p:spPr>
-          <a:xfrm>
-            <a:off x="6355080" y="4663440"/>
-            <a:ext cx="4572000" cy="274320"/>
-          </a:xfrm>
-          <a:prstGeom prst="rect">
-            <a:avLst/>
-          </a:prstGeom>
-          <a:noFill/>
-          <a:ln/>
-        </p:spPr>
-        <p:txBody>
-          <a:bodyPr wrap="square" lIns="0" tIns="0" rIns="0" bIns="0" rtlCol="0" anchor="ctr"/>
-          <a:lstStyle/>
-          <a:p>
-            <a:pPr indent="0" marL="0">
-              <a:buNone/>
-            </a:pPr>
-            <a:r>
-              <a:rPr lang="en-US" sz="1100" i="1" dirty="0">
-                <a:solidFill>
-                  <a:srgbClr val="6B7280"/>
-                </a:solidFill>
-                <a:latin typeface="Calibri" pitchFamily="34" charset="0"/>
-                <a:ea typeface="Calibri" pitchFamily="34" charset="-122"/>
-                <a:cs typeface="Calibri" pitchFamily="34" charset="-120"/>
-              </a:rPr>
-              <a:t>App / Voice / Web: own rollouts after WhatsApp is complete.</a:t>
-            </a:r>
-            <a:endParaRPr lang="en-US" sz="1100" dirty="0"/>
-          </a:p>
-        </p:txBody>
-      </p:sp>
-      <p:sp>
-        <p:nvSpPr>
-          <p:cNvPr id="25" name="Text 23"/>
           <p:cNvSpPr/>
           <p:nvPr/>
         </p:nvSpPr>
@@ -15376,7 +15393,7 @@
       </p:sp>
       <p:sp>
         <p:nvSpPr>
-          <p:cNvPr id="26" name="Shape 24"/>
+          <p:cNvPr id="25" name="Shape 23"/>
           <p:cNvSpPr/>
           <p:nvPr/>
         </p:nvSpPr>
@@ -15403,7 +15420,7 @@
       </p:sp>
       <p:sp>
         <p:nvSpPr>
-          <p:cNvPr id="27" name="Shape 25"/>
+          <p:cNvPr id="26" name="Shape 24"/>
           <p:cNvSpPr/>
           <p:nvPr/>
         </p:nvSpPr>
@@ -15423,7 +15440,7 @@
       </p:sp>
       <p:sp>
         <p:nvSpPr>
-          <p:cNvPr id="28" name="Text 26"/>
+          <p:cNvPr id="27" name="Text 25"/>
           <p:cNvSpPr/>
           <p:nvPr/>
         </p:nvSpPr>
@@ -15462,7 +15479,7 @@
       </p:sp>
       <p:sp>
         <p:nvSpPr>
-          <p:cNvPr id="29" name="Text 27"/>
+          <p:cNvPr id="28" name="Text 26"/>
           <p:cNvSpPr/>
           <p:nvPr/>
         </p:nvSpPr>
@@ -15501,7 +15518,7 @@
       </p:sp>
       <p:sp>
         <p:nvSpPr>
-          <p:cNvPr id="30" name="Shape 28"/>
+          <p:cNvPr id="29" name="Shape 27"/>
           <p:cNvSpPr/>
           <p:nvPr/>
         </p:nvSpPr>
@@ -15528,7 +15545,7 @@
       </p:sp>
       <p:sp>
         <p:nvSpPr>
-          <p:cNvPr id="31" name="Shape 29"/>
+          <p:cNvPr id="30" name="Shape 28"/>
           <p:cNvSpPr/>
           <p:nvPr/>
         </p:nvSpPr>
@@ -15548,7 +15565,7 @@
       </p:sp>
       <p:sp>
         <p:nvSpPr>
-          <p:cNvPr id="32" name="Text 30"/>
+          <p:cNvPr id="31" name="Text 29"/>
           <p:cNvSpPr/>
           <p:nvPr/>
         </p:nvSpPr>
@@ -15587,7 +15604,7 @@
       </p:sp>
       <p:sp>
         <p:nvSpPr>
-          <p:cNvPr id="33" name="Text 31"/>
+          <p:cNvPr id="32" name="Text 30"/>
           <p:cNvSpPr/>
           <p:nvPr/>
         </p:nvSpPr>
@@ -15626,7 +15643,7 @@
       </p:sp>
       <p:sp>
         <p:nvSpPr>
-          <p:cNvPr id="34" name="Shape 32"/>
+          <p:cNvPr id="33" name="Shape 31"/>
           <p:cNvSpPr/>
           <p:nvPr/>
         </p:nvSpPr>
@@ -15653,7 +15670,7 @@
       </p:sp>
       <p:sp>
         <p:nvSpPr>
-          <p:cNvPr id="35" name="Shape 33"/>
+          <p:cNvPr id="34" name="Shape 32"/>
           <p:cNvSpPr/>
           <p:nvPr/>
         </p:nvSpPr>
@@ -15673,7 +15690,7 @@
       </p:sp>
       <p:sp>
         <p:nvSpPr>
-          <p:cNvPr id="36" name="Text 34"/>
+          <p:cNvPr id="35" name="Text 33"/>
           <p:cNvSpPr/>
           <p:nvPr/>
         </p:nvSpPr>
@@ -15712,7 +15729,7 @@
       </p:sp>
       <p:sp>
         <p:nvSpPr>
-          <p:cNvPr id="37" name="Text 35"/>
+          <p:cNvPr id="36" name="Text 34"/>
           <p:cNvSpPr/>
           <p:nvPr/>
         </p:nvSpPr>
@@ -15751,7 +15768,7 @@
       </p:sp>
       <p:sp>
         <p:nvSpPr>
-          <p:cNvPr id="38" name="Text 36"/>
+          <p:cNvPr id="37" name="Text 35"/>
           <p:cNvSpPr/>
           <p:nvPr/>
         </p:nvSpPr>
@@ -15818,7 +15835,7 @@
       </p:sp>
       <p:sp>
         <p:nvSpPr>
-          <p:cNvPr id="39" name="Text 37"/>
+          <p:cNvPr id="38" name="Text 36"/>
           <p:cNvSpPr/>
           <p:nvPr/>
         </p:nvSpPr>
@@ -17310,11 +17327,11 @@
         <p:spPr>
           <a:xfrm>
             <a:off x="640080" y="2148840"/>
-            <a:ext cx="5212080" cy="4160520"/>
+            <a:ext cx="5212080" cy="4251960"/>
           </a:xfrm>
           <a:prstGeom prst="roundRect">
             <a:avLst>
-              <a:gd name="adj" fmla="val 1978"/>
+              <a:gd name="adj" fmla="val 1935"/>
             </a:avLst>
           </a:prstGeom>
           <a:solidFill>
@@ -17402,8 +17419,8 @@
         </p:nvSpPr>
         <p:spPr>
           <a:xfrm rot="2700000">
-            <a:off x="978408" y="2889504"/>
-            <a:ext cx="146304" cy="146304"/>
+            <a:off x="982980" y="2839212"/>
+            <a:ext cx="137160" cy="137160"/>
           </a:xfrm>
           <a:prstGeom prst="rect">
             <a:avLst/>
@@ -17422,24 +17439,24 @@
         </p:nvSpPr>
         <p:spPr>
           <a:xfrm>
-            <a:off x="1280160" y="2834640"/>
-            <a:ext cx="4297680" cy="384048"/>
-          </a:xfrm>
-          <a:prstGeom prst="rect">
-            <a:avLst/>
-          </a:prstGeom>
-          <a:noFill/>
-          <a:ln/>
-        </p:spPr>
-        <p:txBody>
-          <a:bodyPr wrap="square" lIns="0" tIns="0" rIns="0" bIns="0" rtlCol="0" anchor="ctr"/>
-          <a:lstStyle/>
-          <a:p>
-            <a:pPr indent="0" marL="0">
-              <a:buNone/>
-            </a:pPr>
-            <a:r>
-              <a:rPr lang="en-US" sz="1300" b="1" dirty="0">
+            <a:off x="1280160" y="2788920"/>
+            <a:ext cx="4297680" cy="365760"/>
+          </a:xfrm>
+          <a:prstGeom prst="rect">
+            <a:avLst/>
+          </a:prstGeom>
+          <a:noFill/>
+          <a:ln/>
+        </p:spPr>
+        <p:txBody>
+          <a:bodyPr wrap="square" lIns="0" tIns="0" rIns="0" bIns="0" rtlCol="0" anchor="ctr"/>
+          <a:lstStyle/>
+          <a:p>
+            <a:pPr indent="0" marL="0">
+              <a:buNone/>
+            </a:pPr>
+            <a:r>
+              <a:rPr lang="en-US" sz="1250" b="1" dirty="0">
                 <a:solidFill>
                   <a:srgbClr val="111827"/>
                 </a:solidFill>
@@ -17453,7 +17470,7 @@
               <a:buNone/>
             </a:pPr>
             <a:r>
-              <a:rPr lang="en-US" sz="1100" dirty="0">
+              <a:rPr lang="en-US" sz="1050" dirty="0">
                 <a:solidFill>
                   <a:srgbClr val="6B7280"/>
                 </a:solidFill>
@@ -17463,7 +17480,7 @@
               </a:rPr>
               <a:t>   delivery lead, dependency tracker, external sync</a:t>
             </a:r>
-            <a:endParaRPr lang="en-US" sz="1300" dirty="0"/>
+            <a:endParaRPr lang="en-US" sz="1250" dirty="0"/>
           </a:p>
         </p:txBody>
       </p:sp>
@@ -17475,8 +17492,8 @@
         </p:nvSpPr>
         <p:spPr>
           <a:xfrm rot="2700000">
-            <a:off x="978408" y="3438144"/>
-            <a:ext cx="146304" cy="146304"/>
+            <a:off x="982980" y="3314700"/>
+            <a:ext cx="137160" cy="137160"/>
           </a:xfrm>
           <a:prstGeom prst="rect">
             <a:avLst/>
@@ -17495,24 +17512,24 @@
         </p:nvSpPr>
         <p:spPr>
           <a:xfrm>
-            <a:off x="1280160" y="3383280"/>
-            <a:ext cx="4297680" cy="384048"/>
-          </a:xfrm>
-          <a:prstGeom prst="rect">
-            <a:avLst/>
-          </a:prstGeom>
-          <a:noFill/>
-          <a:ln/>
-        </p:spPr>
-        <p:txBody>
-          <a:bodyPr wrap="square" lIns="0" tIns="0" rIns="0" bIns="0" rtlCol="0" anchor="ctr"/>
-          <a:lstStyle/>
-          <a:p>
-            <a:pPr indent="0" marL="0">
-              <a:buNone/>
-            </a:pPr>
-            <a:r>
-              <a:rPr lang="en-US" sz="1300" b="1" dirty="0">
+            <a:off x="1280160" y="3264408"/>
+            <a:ext cx="4297680" cy="365760"/>
+          </a:xfrm>
+          <a:prstGeom prst="rect">
+            <a:avLst/>
+          </a:prstGeom>
+          <a:noFill/>
+          <a:ln/>
+        </p:spPr>
+        <p:txBody>
+          <a:bodyPr wrap="square" lIns="0" tIns="0" rIns="0" bIns="0" rtlCol="0" anchor="ctr"/>
+          <a:lstStyle/>
+          <a:p>
+            <a:pPr indent="0" marL="0">
+              <a:buNone/>
+            </a:pPr>
+            <a:r>
+              <a:rPr lang="en-US" sz="1250" b="1" dirty="0">
                 <a:solidFill>
                   <a:srgbClr val="111827"/>
                 </a:solidFill>
@@ -17526,7 +17543,7 @@
               <a:buNone/>
             </a:pPr>
             <a:r>
-              <a:rPr lang="en-US" sz="1100" dirty="0">
+              <a:rPr lang="en-US" sz="1050" dirty="0">
                 <a:solidFill>
                   <a:srgbClr val="6B7280"/>
                 </a:solidFill>
@@ -17536,7 +17553,7 @@
               </a:rPr>
               <a:t>   business relationship, scope decisions (advisory)</a:t>
             </a:r>
-            <a:endParaRPr lang="en-US" sz="1300" dirty="0"/>
+            <a:endParaRPr lang="en-US" sz="1250" dirty="0"/>
           </a:p>
         </p:txBody>
       </p:sp>
@@ -17548,8 +17565,8 @@
         </p:nvSpPr>
         <p:spPr>
           <a:xfrm rot="2700000">
-            <a:off x="978408" y="3986784"/>
-            <a:ext cx="146304" cy="146304"/>
+            <a:off x="982980" y="3790188"/>
+            <a:ext cx="137160" cy="137160"/>
           </a:xfrm>
           <a:prstGeom prst="rect">
             <a:avLst/>
@@ -17568,24 +17585,24 @@
         </p:nvSpPr>
         <p:spPr>
           <a:xfrm>
-            <a:off x="1280160" y="3931920"/>
-            <a:ext cx="4297680" cy="384048"/>
-          </a:xfrm>
-          <a:prstGeom prst="rect">
-            <a:avLst/>
-          </a:prstGeom>
-          <a:noFill/>
-          <a:ln/>
-        </p:spPr>
-        <p:txBody>
-          <a:bodyPr wrap="square" lIns="0" tIns="0" rIns="0" bIns="0" rtlCol="0" anchor="ctr"/>
-          <a:lstStyle/>
-          <a:p>
-            <a:pPr indent="0" marL="0">
-              <a:buNone/>
-            </a:pPr>
-            <a:r>
-              <a:rPr lang="en-US" sz="1300" b="1" dirty="0">
+            <a:off x="1280160" y="3739896"/>
+            <a:ext cx="4297680" cy="365760"/>
+          </a:xfrm>
+          <a:prstGeom prst="rect">
+            <a:avLst/>
+          </a:prstGeom>
+          <a:noFill/>
+          <a:ln/>
+        </p:spPr>
+        <p:txBody>
+          <a:bodyPr wrap="square" lIns="0" tIns="0" rIns="0" bIns="0" rtlCol="0" anchor="ctr"/>
+          <a:lstStyle/>
+          <a:p>
+            <a:pPr indent="0" marL="0">
+              <a:buNone/>
+            </a:pPr>
+            <a:r>
+              <a:rPr lang="en-US" sz="1250" b="1" dirty="0">
                 <a:solidFill>
                   <a:srgbClr val="111827"/>
                 </a:solidFill>
@@ -17593,13 +17610,13 @@
                 <a:ea typeface="Calibri" pitchFamily="34" charset="-122"/>
                 <a:cs typeface="Calibri" pitchFamily="34" charset="-120"/>
               </a:rPr>
-              <a:t>DevOps / Infra Engineer</a:t>
-            </a:r>
-            <a:pPr indent="0" marL="0">
-              <a:buNone/>
-            </a:pPr>
-            <a:r>
-              <a:rPr lang="en-US" sz="1100" dirty="0">
+              <a:t>Product</a:t>
+            </a:r>
+            <a:pPr indent="0" marL="0">
+              <a:buNone/>
+            </a:pPr>
+            <a:r>
+              <a:rPr lang="en-US" sz="1050" dirty="0">
                 <a:solidFill>
                   <a:srgbClr val="6B7280"/>
                 </a:solidFill>
@@ -17607,9 +17624,9 @@
                 <a:ea typeface="Calibri" pitchFamily="34" charset="-122"/>
                 <a:cs typeface="Calibri" pitchFamily="34" charset="-120"/>
               </a:rPr>
-              <a:t>   owns the on-prem foundation</a:t>
-            </a:r>
-            <a:endParaRPr lang="en-US" sz="1300" dirty="0"/>
+              <a:t>   requirements, backlog, acceptance criteria</a:t>
+            </a:r>
+            <a:endParaRPr lang="en-US" sz="1250" dirty="0"/>
           </a:p>
         </p:txBody>
       </p:sp>
@@ -17621,8 +17638,8 @@
         </p:nvSpPr>
         <p:spPr>
           <a:xfrm rot="2700000">
-            <a:off x="978408" y="4535424"/>
-            <a:ext cx="146304" cy="146304"/>
+            <a:off x="982980" y="4265676"/>
+            <a:ext cx="137160" cy="137160"/>
           </a:xfrm>
           <a:prstGeom prst="rect">
             <a:avLst/>
@@ -17641,24 +17658,24 @@
         </p:nvSpPr>
         <p:spPr>
           <a:xfrm>
-            <a:off x="1280160" y="4480560"/>
-            <a:ext cx="4297680" cy="384048"/>
-          </a:xfrm>
-          <a:prstGeom prst="rect">
-            <a:avLst/>
-          </a:prstGeom>
-          <a:noFill/>
-          <a:ln/>
-        </p:spPr>
-        <p:txBody>
-          <a:bodyPr wrap="square" lIns="0" tIns="0" rIns="0" bIns="0" rtlCol="0" anchor="ctr"/>
-          <a:lstStyle/>
-          <a:p>
-            <a:pPr indent="0" marL="0">
-              <a:buNone/>
-            </a:pPr>
-            <a:r>
-              <a:rPr lang="en-US" sz="1300" b="1" dirty="0">
+            <a:off x="1280160" y="4215384"/>
+            <a:ext cx="4297680" cy="365760"/>
+          </a:xfrm>
+          <a:prstGeom prst="rect">
+            <a:avLst/>
+          </a:prstGeom>
+          <a:noFill/>
+          <a:ln/>
+        </p:spPr>
+        <p:txBody>
+          <a:bodyPr wrap="square" lIns="0" tIns="0" rIns="0" bIns="0" rtlCol="0" anchor="ctr"/>
+          <a:lstStyle/>
+          <a:p>
+            <a:pPr indent="0" marL="0">
+              <a:buNone/>
+            </a:pPr>
+            <a:r>
+              <a:rPr lang="en-US" sz="1250" b="1" dirty="0">
                 <a:solidFill>
                   <a:srgbClr val="111827"/>
                 </a:solidFill>
@@ -17666,13 +17683,13 @@
                 <a:ea typeface="Calibri" pitchFamily="34" charset="-122"/>
                 <a:cs typeface="Calibri" pitchFamily="34" charset="-120"/>
               </a:rPr>
-              <a:t>2 × Platform Developers</a:t>
-            </a:r>
-            <a:pPr indent="0" marL="0">
-              <a:buNone/>
-            </a:pPr>
-            <a:r>
-              <a:rPr lang="en-US" sz="1100" dirty="0">
+              <a:t>DevOps / Infra Engineer</a:t>
+            </a:r>
+            <a:pPr indent="0" marL="0">
+              <a:buNone/>
+            </a:pPr>
+            <a:r>
+              <a:rPr lang="en-US" sz="1050" dirty="0">
                 <a:solidFill>
                   <a:srgbClr val="6B7280"/>
                 </a:solidFill>
@@ -17680,9 +17697,9 @@
                 <a:ea typeface="Calibri" pitchFamily="34" charset="-122"/>
                 <a:cs typeface="Calibri" pitchFamily="34" charset="-120"/>
               </a:rPr>
-              <a:t>   the core build capacity</a:t>
-            </a:r>
-            <a:endParaRPr lang="en-US" sz="1300" dirty="0"/>
+              <a:t>   owns the on-prem foundation</a:t>
+            </a:r>
+            <a:endParaRPr lang="en-US" sz="1250" dirty="0"/>
           </a:p>
         </p:txBody>
       </p:sp>
@@ -17694,8 +17711,8 @@
         </p:nvSpPr>
         <p:spPr>
           <a:xfrm rot="2700000">
-            <a:off x="978408" y="5084064"/>
-            <a:ext cx="146304" cy="146304"/>
+            <a:off x="982980" y="4741164"/>
+            <a:ext cx="137160" cy="137160"/>
           </a:xfrm>
           <a:prstGeom prst="rect">
             <a:avLst/>
@@ -17714,24 +17731,24 @@
         </p:nvSpPr>
         <p:spPr>
           <a:xfrm>
-            <a:off x="1280160" y="5029200"/>
-            <a:ext cx="4297680" cy="384048"/>
-          </a:xfrm>
-          <a:prstGeom prst="rect">
-            <a:avLst/>
-          </a:prstGeom>
-          <a:noFill/>
-          <a:ln/>
-        </p:spPr>
-        <p:txBody>
-          <a:bodyPr wrap="square" lIns="0" tIns="0" rIns="0" bIns="0" rtlCol="0" anchor="ctr"/>
-          <a:lstStyle/>
-          <a:p>
-            <a:pPr indent="0" marL="0">
-              <a:buNone/>
-            </a:pPr>
-            <a:r>
-              <a:rPr lang="en-US" sz="1300" b="1" dirty="0">
+            <a:off x="1280160" y="4690872"/>
+            <a:ext cx="4297680" cy="365760"/>
+          </a:xfrm>
+          <a:prstGeom prst="rect">
+            <a:avLst/>
+          </a:prstGeom>
+          <a:noFill/>
+          <a:ln/>
+        </p:spPr>
+        <p:txBody>
+          <a:bodyPr wrap="square" lIns="0" tIns="0" rIns="0" bIns="0" rtlCol="0" anchor="ctr"/>
+          <a:lstStyle/>
+          <a:p>
+            <a:pPr indent="0" marL="0">
+              <a:buNone/>
+            </a:pPr>
+            <a:r>
+              <a:rPr lang="en-US" sz="1250" b="1" dirty="0">
                 <a:solidFill>
                   <a:srgbClr val="111827"/>
                 </a:solidFill>
@@ -17739,13 +17756,13 @@
                 <a:ea typeface="Calibri" pitchFamily="34" charset="-122"/>
                 <a:cs typeface="Calibri" pitchFamily="34" charset="-120"/>
               </a:rPr>
-              <a:t>AI / Prompt Engineer</a:t>
-            </a:r>
-            <a:pPr indent="0" marL="0">
-              <a:buNone/>
-            </a:pPr>
-            <a:r>
-              <a:rPr lang="en-US" sz="1100" dirty="0">
+              <a:t>2 × Platform Developers</a:t>
+            </a:r>
+            <a:pPr indent="0" marL="0">
+              <a:buNone/>
+            </a:pPr>
+            <a:r>
+              <a:rPr lang="en-US" sz="1050" dirty="0">
                 <a:solidFill>
                   <a:srgbClr val="6B7280"/>
                 </a:solidFill>
@@ -17753,9 +17770,9 @@
                 <a:ea typeface="Calibri" pitchFamily="34" charset="-122"/>
                 <a:cs typeface="Calibri" pitchFamily="34" charset="-120"/>
               </a:rPr>
-              <a:t>   agents, guardrails, tuning</a:t>
-            </a:r>
-            <a:endParaRPr lang="en-US" sz="1300" dirty="0"/>
+              <a:t>   the core build capacity</a:t>
+            </a:r>
+            <a:endParaRPr lang="en-US" sz="1250" dirty="0"/>
           </a:p>
         </p:txBody>
       </p:sp>
@@ -17767,8 +17784,8 @@
         </p:nvSpPr>
         <p:spPr>
           <a:xfrm rot="2700000">
-            <a:off x="978408" y="5632704"/>
-            <a:ext cx="146304" cy="146304"/>
+            <a:off x="982980" y="5216652"/>
+            <a:ext cx="137160" cy="137160"/>
           </a:xfrm>
           <a:prstGeom prst="rect">
             <a:avLst/>
@@ -17787,24 +17804,24 @@
         </p:nvSpPr>
         <p:spPr>
           <a:xfrm>
-            <a:off x="1280160" y="5577840"/>
-            <a:ext cx="4297680" cy="384048"/>
-          </a:xfrm>
-          <a:prstGeom prst="rect">
-            <a:avLst/>
-          </a:prstGeom>
-          <a:noFill/>
-          <a:ln/>
-        </p:spPr>
-        <p:txBody>
-          <a:bodyPr wrap="square" lIns="0" tIns="0" rIns="0" bIns="0" rtlCol="0" anchor="ctr"/>
-          <a:lstStyle/>
-          <a:p>
-            <a:pPr indent="0" marL="0">
-              <a:buNone/>
-            </a:pPr>
-            <a:r>
-              <a:rPr lang="en-US" sz="1300" b="1" dirty="0">
+            <a:off x="1280160" y="5166360"/>
+            <a:ext cx="4297680" cy="365760"/>
+          </a:xfrm>
+          <a:prstGeom prst="rect">
+            <a:avLst/>
+          </a:prstGeom>
+          <a:noFill/>
+          <a:ln/>
+        </p:spPr>
+        <p:txBody>
+          <a:bodyPr wrap="square" lIns="0" tIns="0" rIns="0" bIns="0" rtlCol="0" anchor="ctr"/>
+          <a:lstStyle/>
+          <a:p>
+            <a:pPr indent="0" marL="0">
+              <a:buNone/>
+            </a:pPr>
+            <a:r>
+              <a:rPr lang="en-US" sz="1250" b="1" dirty="0">
                 <a:solidFill>
                   <a:srgbClr val="111827"/>
                 </a:solidFill>
@@ -17812,13 +17829,86 @@
                 <a:ea typeface="Calibri" pitchFamily="34" charset="-122"/>
                 <a:cs typeface="Calibri" pitchFamily="34" charset="-120"/>
               </a:rPr>
+              <a:t>AI / Prompt Engineer</a:t>
+            </a:r>
+            <a:pPr indent="0" marL="0">
+              <a:buNone/>
+            </a:pPr>
+            <a:r>
+              <a:rPr lang="en-US" sz="1050" dirty="0">
+                <a:solidFill>
+                  <a:srgbClr val="6B7280"/>
+                </a:solidFill>
+                <a:latin typeface="Calibri" pitchFamily="34" charset="0"/>
+                <a:ea typeface="Calibri" pitchFamily="34" charset="-122"/>
+                <a:cs typeface="Calibri" pitchFamily="34" charset="-120"/>
+              </a:rPr>
+              <a:t>   agents, guardrails, tuning</a:t>
+            </a:r>
+            <a:endParaRPr lang="en-US" sz="1250" dirty="0"/>
+          </a:p>
+        </p:txBody>
+      </p:sp>
+      <p:sp>
+        <p:nvSpPr>
+          <p:cNvPr id="21" name="Shape 19"/>
+          <p:cNvSpPr/>
+          <p:nvPr/>
+        </p:nvSpPr>
+        <p:spPr>
+          <a:xfrm rot="2700000">
+            <a:off x="982980" y="5692140"/>
+            <a:ext cx="137160" cy="137160"/>
+          </a:xfrm>
+          <a:prstGeom prst="rect">
+            <a:avLst/>
+          </a:prstGeom>
+          <a:solidFill>
+            <a:srgbClr val="F06A22"/>
+          </a:solidFill>
+          <a:ln/>
+        </p:spPr>
+      </p:sp>
+      <p:sp>
+        <p:nvSpPr>
+          <p:cNvPr id="22" name="Text 20"/>
+          <p:cNvSpPr/>
+          <p:nvPr/>
+        </p:nvSpPr>
+        <p:spPr>
+          <a:xfrm>
+            <a:off x="1280160" y="5641848"/>
+            <a:ext cx="4297680" cy="365760"/>
+          </a:xfrm>
+          <a:prstGeom prst="rect">
+            <a:avLst/>
+          </a:prstGeom>
+          <a:noFill/>
+          <a:ln/>
+        </p:spPr>
+        <p:txBody>
+          <a:bodyPr wrap="square" lIns="0" tIns="0" rIns="0" bIns="0" rtlCol="0" anchor="ctr"/>
+          <a:lstStyle/>
+          <a:p>
+            <a:pPr indent="0" marL="0">
+              <a:buNone/>
+            </a:pPr>
+            <a:r>
+              <a:rPr lang="en-US" sz="1250" b="1" dirty="0">
+                <a:solidFill>
+                  <a:srgbClr val="111827"/>
+                </a:solidFill>
+                <a:latin typeface="Calibri" pitchFamily="34" charset="0"/>
+                <a:ea typeface="Calibri" pitchFamily="34" charset="-122"/>
+                <a:cs typeface="Calibri" pitchFamily="34" charset="-120"/>
+              </a:rPr>
               <a:t>QA / Test Engineer</a:t>
             </a:r>
             <a:pPr indent="0" marL="0">
               <a:buNone/>
             </a:pPr>
             <a:r>
-              <a:rPr lang="en-US" sz="1100" dirty="0">
+              <a:rPr lang="en-US" sz="1050" dirty="0">
                 <a:solidFill>
                   <a:srgbClr val="6B7280"/>
                 </a:solidFill>
@@ -17828,24 +17918,24 @@
               </a:rPr>
               <a:t>   owns the testing funnel</a:t>
             </a:r>
-            <a:endParaRPr lang="en-US" sz="1300" dirty="0"/>
-          </a:p>
-        </p:txBody>
-      </p:sp>
-      <p:sp>
-        <p:nvSpPr>
-          <p:cNvPr id="21" name="Shape 19"/>
+            <a:endParaRPr lang="en-US" sz="1250" dirty="0"/>
+          </a:p>
+        </p:txBody>
+      </p:sp>
+      <p:sp>
+        <p:nvSpPr>
+          <p:cNvPr id="23" name="Shape 21"/>
           <p:cNvSpPr/>
           <p:nvPr/>
         </p:nvSpPr>
         <p:spPr>
           <a:xfrm>
             <a:off x="6339535" y="2148840"/>
-            <a:ext cx="5212080" cy="4160520"/>
+            <a:ext cx="5212080" cy="4251960"/>
           </a:xfrm>
           <a:prstGeom prst="roundRect">
             <a:avLst>
-              <a:gd name="adj" fmla="val 1978"/>
+              <a:gd name="adj" fmla="val 1935"/>
             </a:avLst>
           </a:prstGeom>
           <a:solidFill>
@@ -17868,7 +17958,7 @@
       </p:sp>
       <p:sp>
         <p:nvSpPr>
-          <p:cNvPr id="22" name="Shape 20"/>
+          <p:cNvPr id="24" name="Shape 22"/>
           <p:cNvSpPr/>
           <p:nvPr/>
         </p:nvSpPr>
@@ -17888,7 +17978,7 @@
       </p:sp>
       <p:sp>
         <p:nvSpPr>
-          <p:cNvPr id="23" name="Text 21"/>
+          <p:cNvPr id="25" name="Text 23"/>
           <p:cNvSpPr/>
           <p:nvPr/>
         </p:nvSpPr>
@@ -17927,14 +18017,14 @@
       </p:sp>
       <p:sp>
         <p:nvSpPr>
-          <p:cNvPr id="24" name="Shape 22"/>
+          <p:cNvPr id="26" name="Shape 24"/>
           <p:cNvSpPr/>
           <p:nvPr/>
         </p:nvSpPr>
         <p:spPr>
           <a:xfrm rot="2700000">
-            <a:off x="6677863" y="2889504"/>
-            <a:ext cx="146304" cy="146304"/>
+            <a:off x="6682435" y="2839212"/>
+            <a:ext cx="137160" cy="137160"/>
           </a:xfrm>
           <a:prstGeom prst="rect">
             <a:avLst/>
@@ -17947,30 +18037,30 @@
       </p:sp>
       <p:sp>
         <p:nvSpPr>
-          <p:cNvPr id="25" name="Text 23"/>
-          <p:cNvSpPr/>
-          <p:nvPr/>
-        </p:nvSpPr>
-        <p:spPr>
-          <a:xfrm>
-            <a:off x="6979615" y="2834640"/>
-            <a:ext cx="4297680" cy="384048"/>
-          </a:xfrm>
-          <a:prstGeom prst="rect">
-            <a:avLst/>
-          </a:prstGeom>
-          <a:noFill/>
-          <a:ln/>
-        </p:spPr>
-        <p:txBody>
-          <a:bodyPr wrap="square" lIns="0" tIns="0" rIns="0" bIns="0" rtlCol="0" anchor="ctr"/>
-          <a:lstStyle/>
-          <a:p>
-            <a:pPr indent="0" marL="0">
-              <a:buNone/>
-            </a:pPr>
-            <a:r>
-              <a:rPr lang="en-US" sz="1300" b="1" dirty="0">
+          <p:cNvPr id="27" name="Text 25"/>
+          <p:cNvSpPr/>
+          <p:nvPr/>
+        </p:nvSpPr>
+        <p:spPr>
+          <a:xfrm>
+            <a:off x="6979615" y="2788920"/>
+            <a:ext cx="4297680" cy="365760"/>
+          </a:xfrm>
+          <a:prstGeom prst="rect">
+            <a:avLst/>
+          </a:prstGeom>
+          <a:noFill/>
+          <a:ln/>
+        </p:spPr>
+        <p:txBody>
+          <a:bodyPr wrap="square" lIns="0" tIns="0" rIns="0" bIns="0" rtlCol="0" anchor="ctr"/>
+          <a:lstStyle/>
+          <a:p>
+            <a:pPr indent="0" marL="0">
+              <a:buNone/>
+            </a:pPr>
+            <a:r>
+              <a:rPr lang="en-US" sz="1250" b="1" dirty="0">
                 <a:solidFill>
                   <a:srgbClr val="111827"/>
                 </a:solidFill>
@@ -17984,7 +18074,7 @@
               <a:buNone/>
             </a:pPr>
             <a:r>
-              <a:rPr lang="en-US" sz="1100" dirty="0">
+              <a:rPr lang="en-US" sz="1050" dirty="0">
                 <a:solidFill>
                   <a:srgbClr val="6B7280"/>
                 </a:solidFill>
@@ -17994,20 +18084,20 @@
               </a:rPr>
               <a:t>   single coordination point - the must-have</a:t>
             </a:r>
-            <a:endParaRPr lang="en-US" sz="1300" dirty="0"/>
-          </a:p>
-        </p:txBody>
-      </p:sp>
-      <p:sp>
-        <p:nvSpPr>
-          <p:cNvPr id="26" name="Shape 24"/>
+            <a:endParaRPr lang="en-US" sz="1250" dirty="0"/>
+          </a:p>
+        </p:txBody>
+      </p:sp>
+      <p:sp>
+        <p:nvSpPr>
+          <p:cNvPr id="28" name="Shape 26"/>
           <p:cNvSpPr/>
           <p:nvPr/>
         </p:nvSpPr>
         <p:spPr>
           <a:xfrm rot="2700000">
-            <a:off x="6677863" y="3438144"/>
-            <a:ext cx="146304" cy="146304"/>
+            <a:off x="6682435" y="3314700"/>
+            <a:ext cx="137160" cy="137160"/>
           </a:xfrm>
           <a:prstGeom prst="rect">
             <a:avLst/>
@@ -18020,30 +18110,30 @@
       </p:sp>
       <p:sp>
         <p:nvSpPr>
-          <p:cNvPr id="27" name="Text 25"/>
-          <p:cNvSpPr/>
-          <p:nvPr/>
-        </p:nvSpPr>
-        <p:spPr>
-          <a:xfrm>
-            <a:off x="6979615" y="3383280"/>
-            <a:ext cx="4297680" cy="384048"/>
-          </a:xfrm>
-          <a:prstGeom prst="rect">
-            <a:avLst/>
-          </a:prstGeom>
-          <a:noFill/>
-          <a:ln/>
-        </p:spPr>
-        <p:txBody>
-          <a:bodyPr wrap="square" lIns="0" tIns="0" rIns="0" bIns="0" rtlCol="0" anchor="ctr"/>
-          <a:lstStyle/>
-          <a:p>
-            <a:pPr indent="0" marL="0">
-              <a:buNone/>
-            </a:pPr>
-            <a:r>
-              <a:rPr lang="en-US" sz="1300" b="1" dirty="0">
+          <p:cNvPr id="29" name="Text 27"/>
+          <p:cNvSpPr/>
+          <p:nvPr/>
+        </p:nvSpPr>
+        <p:spPr>
+          <a:xfrm>
+            <a:off x="6979615" y="3264408"/>
+            <a:ext cx="4297680" cy="365760"/>
+          </a:xfrm>
+          <a:prstGeom prst="rect">
+            <a:avLst/>
+          </a:prstGeom>
+          <a:noFill/>
+          <a:ln/>
+        </p:spPr>
+        <p:txBody>
+          <a:bodyPr wrap="square" lIns="0" tIns="0" rIns="0" bIns="0" rtlCol="0" anchor="ctr"/>
+          <a:lstStyle/>
+          <a:p>
+            <a:pPr indent="0" marL="0">
+              <a:buNone/>
+            </a:pPr>
+            <a:r>
+              <a:rPr lang="en-US" sz="1250" b="1" dirty="0">
                 <a:solidFill>
                   <a:srgbClr val="111827"/>
                 </a:solidFill>
@@ -18057,7 +18147,7 @@
               <a:buNone/>
             </a:pPr>
             <a:r>
-              <a:rPr lang="en-US" sz="1100" dirty="0">
+              <a:rPr lang="en-US" sz="1050" dirty="0">
                 <a:solidFill>
                   <a:srgbClr val="6B7280"/>
                 </a:solidFill>
@@ -18067,20 +18157,20 @@
               </a:rPr>
               <a:t>   provisions envs, access, GPU</a:t>
             </a:r>
-            <a:endParaRPr lang="en-US" sz="1300" dirty="0"/>
-          </a:p>
-        </p:txBody>
-      </p:sp>
-      <p:sp>
-        <p:nvSpPr>
-          <p:cNvPr id="28" name="Shape 26"/>
+            <a:endParaRPr lang="en-US" sz="1250" dirty="0"/>
+          </a:p>
+        </p:txBody>
+      </p:sp>
+      <p:sp>
+        <p:nvSpPr>
+          <p:cNvPr id="30" name="Shape 28"/>
           <p:cNvSpPr/>
           <p:nvPr/>
         </p:nvSpPr>
         <p:spPr>
           <a:xfrm rot="2700000">
-            <a:off x="6677863" y="3986784"/>
-            <a:ext cx="146304" cy="146304"/>
+            <a:off x="6682435" y="3790188"/>
+            <a:ext cx="137160" cy="137160"/>
           </a:xfrm>
           <a:prstGeom prst="rect">
             <a:avLst/>
@@ -18093,30 +18183,30 @@
       </p:sp>
       <p:sp>
         <p:nvSpPr>
-          <p:cNvPr id="29" name="Text 27"/>
-          <p:cNvSpPr/>
-          <p:nvPr/>
-        </p:nvSpPr>
-        <p:spPr>
-          <a:xfrm>
-            <a:off x="6979615" y="3931920"/>
-            <a:ext cx="4297680" cy="384048"/>
-          </a:xfrm>
-          <a:prstGeom prst="rect">
-            <a:avLst/>
-          </a:prstGeom>
-          <a:noFill/>
-          <a:ln/>
-        </p:spPr>
-        <p:txBody>
-          <a:bodyPr wrap="square" lIns="0" tIns="0" rIns="0" bIns="0" rtlCol="0" anchor="ctr"/>
-          <a:lstStyle/>
-          <a:p>
-            <a:pPr indent="0" marL="0">
-              <a:buNone/>
-            </a:pPr>
-            <a:r>
-              <a:rPr lang="en-US" sz="1300" b="1" dirty="0">
+          <p:cNvPr id="31" name="Text 29"/>
+          <p:cNvSpPr/>
+          <p:nvPr/>
+        </p:nvSpPr>
+        <p:spPr>
+          <a:xfrm>
+            <a:off x="6979615" y="3739896"/>
+            <a:ext cx="4297680" cy="365760"/>
+          </a:xfrm>
+          <a:prstGeom prst="rect">
+            <a:avLst/>
+          </a:prstGeom>
+          <a:noFill/>
+          <a:ln/>
+        </p:spPr>
+        <p:txBody>
+          <a:bodyPr wrap="square" lIns="0" tIns="0" rIns="0" bIns="0" rtlCol="0" anchor="ctr"/>
+          <a:lstStyle/>
+          <a:p>
+            <a:pPr indent="0" marL="0">
+              <a:buNone/>
+            </a:pPr>
+            <a:r>
+              <a:rPr lang="en-US" sz="1250" b="1" dirty="0">
                 <a:solidFill>
                   <a:srgbClr val="111827"/>
                 </a:solidFill>
@@ -18130,7 +18220,7 @@
               <a:buNone/>
             </a:pPr>
             <a:r>
-              <a:rPr lang="en-US" sz="1100" dirty="0">
+              <a:rPr lang="en-US" sz="1050" dirty="0">
                 <a:solidFill>
                   <a:srgbClr val="6B7280"/>
                 </a:solidFill>
@@ -18140,20 +18230,20 @@
               </a:rPr>
               <a:t>   Swagger + comprehension Q&amp;A</a:t>
             </a:r>
-            <a:endParaRPr lang="en-US" sz="1300" dirty="0"/>
-          </a:p>
-        </p:txBody>
-      </p:sp>
-      <p:sp>
-        <p:nvSpPr>
-          <p:cNvPr id="30" name="Shape 28"/>
+            <a:endParaRPr lang="en-US" sz="1250" dirty="0"/>
+          </a:p>
+        </p:txBody>
+      </p:sp>
+      <p:sp>
+        <p:nvSpPr>
+          <p:cNvPr id="32" name="Shape 30"/>
           <p:cNvSpPr/>
           <p:nvPr/>
         </p:nvSpPr>
         <p:spPr>
           <a:xfrm rot="2700000">
-            <a:off x="6677863" y="4535424"/>
-            <a:ext cx="146304" cy="146304"/>
+            <a:off x="6682435" y="4265676"/>
+            <a:ext cx="137160" cy="137160"/>
           </a:xfrm>
           <a:prstGeom prst="rect">
             <a:avLst/>
@@ -18166,30 +18256,30 @@
       </p:sp>
       <p:sp>
         <p:nvSpPr>
-          <p:cNvPr id="31" name="Text 29"/>
-          <p:cNvSpPr/>
-          <p:nvPr/>
-        </p:nvSpPr>
-        <p:spPr>
-          <a:xfrm>
-            <a:off x="6979615" y="4480560"/>
-            <a:ext cx="4297680" cy="384048"/>
-          </a:xfrm>
-          <a:prstGeom prst="rect">
-            <a:avLst/>
-          </a:prstGeom>
-          <a:noFill/>
-          <a:ln/>
-        </p:spPr>
-        <p:txBody>
-          <a:bodyPr wrap="square" lIns="0" tIns="0" rIns="0" bIns="0" rtlCol="0" anchor="ctr"/>
-          <a:lstStyle/>
-          <a:p>
-            <a:pPr indent="0" marL="0">
-              <a:buNone/>
-            </a:pPr>
-            <a:r>
-              <a:rPr lang="en-US" sz="1300" b="1" dirty="0">
+          <p:cNvPr id="33" name="Text 31"/>
+          <p:cNvSpPr/>
+          <p:nvPr/>
+        </p:nvSpPr>
+        <p:spPr>
+          <a:xfrm>
+            <a:off x="6979615" y="4215384"/>
+            <a:ext cx="4297680" cy="365760"/>
+          </a:xfrm>
+          <a:prstGeom prst="rect">
+            <a:avLst/>
+          </a:prstGeom>
+          <a:noFill/>
+          <a:ln/>
+        </p:spPr>
+        <p:txBody>
+          <a:bodyPr wrap="square" lIns="0" tIns="0" rIns="0" bIns="0" rtlCol="0" anchor="ctr"/>
+          <a:lstStyle/>
+          <a:p>
+            <a:pPr indent="0" marL="0">
+              <a:buNone/>
+            </a:pPr>
+            <a:r>
+              <a:rPr lang="en-US" sz="1250" b="1" dirty="0">
                 <a:solidFill>
                   <a:srgbClr val="111827"/>
                 </a:solidFill>
@@ -18203,7 +18293,7 @@
               <a:buNone/>
             </a:pPr>
             <a:r>
-              <a:rPr lang="en-US" sz="1100" dirty="0">
+              <a:rPr lang="en-US" sz="1050" dirty="0">
                 <a:solidFill>
                   <a:srgbClr val="6B7280"/>
                 </a:solidFill>
@@ -18213,20 +18303,20 @@
               </a:rPr>
               <a:t>   scanning, pentest, prod access</a:t>
             </a:r>
-            <a:endParaRPr lang="en-US" sz="1300" dirty="0"/>
-          </a:p>
-        </p:txBody>
-      </p:sp>
-      <p:sp>
-        <p:nvSpPr>
-          <p:cNvPr id="32" name="Shape 30"/>
+            <a:endParaRPr lang="en-US" sz="1250" dirty="0"/>
+          </a:p>
+        </p:txBody>
+      </p:sp>
+      <p:sp>
+        <p:nvSpPr>
+          <p:cNvPr id="34" name="Shape 32"/>
           <p:cNvSpPr/>
           <p:nvPr/>
         </p:nvSpPr>
         <p:spPr>
           <a:xfrm rot="2700000">
-            <a:off x="6677863" y="5084064"/>
-            <a:ext cx="146304" cy="146304"/>
+            <a:off x="6682435" y="4741164"/>
+            <a:ext cx="137160" cy="137160"/>
           </a:xfrm>
           <a:prstGeom prst="rect">
             <a:avLst/>
@@ -18239,30 +18329,30 @@
       </p:sp>
       <p:sp>
         <p:nvSpPr>
-          <p:cNvPr id="33" name="Text 31"/>
-          <p:cNvSpPr/>
-          <p:nvPr/>
-        </p:nvSpPr>
-        <p:spPr>
-          <a:xfrm>
-            <a:off x="6979615" y="5029200"/>
-            <a:ext cx="4297680" cy="384048"/>
-          </a:xfrm>
-          <a:prstGeom prst="rect">
-            <a:avLst/>
-          </a:prstGeom>
-          <a:noFill/>
-          <a:ln/>
-        </p:spPr>
-        <p:txBody>
-          <a:bodyPr wrap="square" lIns="0" tIns="0" rIns="0" bIns="0" rtlCol="0" anchor="ctr"/>
-          <a:lstStyle/>
-          <a:p>
-            <a:pPr indent="0" marL="0">
-              <a:buNone/>
-            </a:pPr>
-            <a:r>
-              <a:rPr lang="en-US" sz="1300" b="1" dirty="0">
+          <p:cNvPr id="35" name="Text 33"/>
+          <p:cNvSpPr/>
+          <p:nvPr/>
+        </p:nvSpPr>
+        <p:spPr>
+          <a:xfrm>
+            <a:off x="6979615" y="4690872"/>
+            <a:ext cx="4297680" cy="365760"/>
+          </a:xfrm>
+          <a:prstGeom prst="rect">
+            <a:avLst/>
+          </a:prstGeom>
+          <a:noFill/>
+          <a:ln/>
+        </p:spPr>
+        <p:txBody>
+          <a:bodyPr wrap="square" lIns="0" tIns="0" rIns="0" bIns="0" rtlCol="0" anchor="ctr"/>
+          <a:lstStyle/>
+          <a:p>
+            <a:pPr indent="0" marL="0">
+              <a:buNone/>
+            </a:pPr>
+            <a:r>
+              <a:rPr lang="en-US" sz="1250" b="1" dirty="0">
                 <a:solidFill>
                   <a:srgbClr val="111827"/>
                 </a:solidFill>
@@ -18276,7 +18366,7 @@
               <a:buNone/>
             </a:pPr>
             <a:r>
-              <a:rPr lang="en-US" sz="1100" dirty="0">
+              <a:rPr lang="en-US" sz="1050" dirty="0">
                 <a:solidFill>
                   <a:srgbClr val="6B7280"/>
                 </a:solidFill>
@@ -18286,13 +18376,13 @@
               </a:rPr>
               <a:t>   top intents, UAT, AI response correctness</a:t>
             </a:r>
-            <a:endParaRPr lang="en-US" sz="1300" dirty="0"/>
-          </a:p>
-        </p:txBody>
-      </p:sp>
-      <p:sp>
-        <p:nvSpPr>
-          <p:cNvPr id="34" name="Text 32"/>
+            <a:endParaRPr lang="en-US" sz="1250" dirty="0"/>
+          </a:p>
+        </p:txBody>
+      </p:sp>
+      <p:sp>
+        <p:nvSpPr>
+          <p:cNvPr id="36" name="Text 34"/>
           <p:cNvSpPr/>
           <p:nvPr/>
         </p:nvSpPr>
@@ -18359,7 +18449,7 @@
       </p:sp>
       <p:sp>
         <p:nvSpPr>
-          <p:cNvPr id="35" name="Text 33"/>
+          <p:cNvPr id="37" name="Text 35"/>
           <p:cNvSpPr/>
           <p:nvPr/>
         </p:nvSpPr>

</xml_diff>

<commit_message>
Update root PPTX: V0/V1/V2 timeline + Product role + 90% target + no benchmark wording
Co-Authored-By: Claude Sonnet 4.6 <noreply@anthropic.com>
</commit_message>
<xml_diff>
--- a/Notch-Bullet-Kickoff.pptx
+++ b/Notch-Bullet-Kickoff.pptx
@@ -9225,7 +9225,7 @@
                 <a:ea typeface="Calibri" pitchFamily="34" charset="-122"/>
                 <a:cs typeface="Calibri" pitchFamily="34" charset="-120"/>
               </a:rPr>
-              <a:t>THE BENCHMARK WE DEFEND</a:t>
+              <a:t>NOTCH TARGET</a:t>
             </a:r>
             <a:endParaRPr lang="en-US" sz="1100" dirty="0"/>
           </a:p>
@@ -9264,7 +9264,7 @@
                 <a:ea typeface="Calibri" pitchFamily="34" charset="-122"/>
                 <a:cs typeface="Calibri" pitchFamily="34" charset="-120"/>
               </a:rPr>
-              <a:t>70-73%</a:t>
+              <a:t>90%</a:t>
             </a:r>
             <a:endParaRPr lang="en-US" sz="4000" dirty="0"/>
           </a:p>
@@ -13455,7 +13455,7 @@
                 <a:ea typeface="Calibri" pitchFamily="34" charset="-122"/>
                 <a:cs typeface="Calibri" pitchFamily="34" charset="-120"/>
               </a:rPr>
-              <a:t>MVP</a:t>
+              <a:t>WA V0</a:t>
             </a:r>
             <a:endParaRPr lang="en-US" sz="1200" dirty="0"/>
           </a:p>
@@ -13553,7 +13553,7 @@
                 <a:ea typeface="Calibri" pitchFamily="34" charset="-122"/>
                 <a:cs typeface="Calibri" pitchFamily="34" charset="-120"/>
               </a:rPr>
-              <a:t>WA Full</a:t>
+              <a:t>WA V1</a:t>
             </a:r>
             <a:endParaRPr lang="en-US" sz="1200" dirty="0"/>
           </a:p>
@@ -13601,6 +13601,104 @@
       <p:sp>
         <p:nvSpPr>
           <p:cNvPr id="33" name="Shape 31"/>
+          <p:cNvSpPr/>
+          <p:nvPr/>
+        </p:nvSpPr>
+        <p:spPr>
+          <a:xfrm rot="2700000">
+            <a:off x="5976976" y="3172968"/>
+            <a:ext cx="237744" cy="237744"/>
+          </a:xfrm>
+          <a:prstGeom prst="rect">
+            <a:avLst/>
+          </a:prstGeom>
+          <a:solidFill>
+            <a:srgbClr val="F06A22"/>
+          </a:solidFill>
+          <a:ln/>
+        </p:spPr>
+      </p:sp>
+      <p:sp>
+        <p:nvSpPr>
+          <p:cNvPr id="34" name="Text 32"/>
+          <p:cNvSpPr/>
+          <p:nvPr/>
+        </p:nvSpPr>
+        <p:spPr>
+          <a:xfrm>
+            <a:off x="5455768" y="2724912"/>
+            <a:ext cx="1280160" cy="237744"/>
+          </a:xfrm>
+          <a:prstGeom prst="rect">
+            <a:avLst/>
+          </a:prstGeom>
+          <a:noFill/>
+          <a:ln/>
+        </p:spPr>
+        <p:txBody>
+          <a:bodyPr wrap="square" lIns="0" tIns="0" rIns="0" bIns="0" rtlCol="0" anchor="ctr"/>
+          <a:lstStyle/>
+          <a:p>
+            <a:pPr algn="ctr" indent="0" marL="0">
+              <a:buNone/>
+            </a:pPr>
+            <a:r>
+              <a:rPr lang="en-US" sz="1200" b="1" dirty="0">
+                <a:solidFill>
+                  <a:srgbClr val="111827"/>
+                </a:solidFill>
+                <a:latin typeface="Calibri" pitchFamily="34" charset="0"/>
+                <a:ea typeface="Calibri" pitchFamily="34" charset="-122"/>
+                <a:cs typeface="Calibri" pitchFamily="34" charset="-120"/>
+              </a:rPr>
+              <a:t>WA V2</a:t>
+            </a:r>
+            <a:endParaRPr lang="en-US" sz="1200" dirty="0"/>
+          </a:p>
+        </p:txBody>
+      </p:sp>
+      <p:sp>
+        <p:nvSpPr>
+          <p:cNvPr id="35" name="Text 33"/>
+          <p:cNvSpPr/>
+          <p:nvPr/>
+        </p:nvSpPr>
+        <p:spPr>
+          <a:xfrm>
+            <a:off x="5455768" y="2926080"/>
+            <a:ext cx="1280160" cy="201168"/>
+          </a:xfrm>
+          <a:prstGeom prst="rect">
+            <a:avLst/>
+          </a:prstGeom>
+          <a:noFill/>
+          <a:ln/>
+        </p:spPr>
+        <p:txBody>
+          <a:bodyPr wrap="square" lIns="0" tIns="0" rIns="0" bIns="0" rtlCol="0" anchor="ctr"/>
+          <a:lstStyle/>
+          <a:p>
+            <a:pPr algn="ctr" indent="0" marL="0">
+              <a:buNone/>
+            </a:pPr>
+            <a:r>
+              <a:rPr lang="en-US" sz="950" dirty="0">
+                <a:solidFill>
+                  <a:srgbClr val="9CA3AF"/>
+                </a:solidFill>
+                <a:latin typeface="Calibri" pitchFamily="34" charset="0"/>
+                <a:ea typeface="Calibri" pitchFamily="34" charset="-122"/>
+                <a:cs typeface="Calibri" pitchFamily="34" charset="-120"/>
+              </a:rPr>
+              <a:t>Feb</a:t>
+            </a:r>
+            <a:endParaRPr lang="en-US" sz="950" dirty="0"/>
+          </a:p>
+        </p:txBody>
+      </p:sp>
+      <p:sp>
+        <p:nvSpPr>
+          <p:cNvPr id="36" name="Shape 34"/>
           <p:cNvSpPr/>
           <p:nvPr/>
         </p:nvSpPr>
@@ -13620,7 +13718,7 @@
       </p:sp>
       <p:sp>
         <p:nvSpPr>
-          <p:cNvPr id="34" name="Text 32"/>
+          <p:cNvPr id="37" name="Text 35"/>
           <p:cNvSpPr/>
           <p:nvPr/>
         </p:nvSpPr>
@@ -13659,7 +13757,7 @@
       </p:sp>
       <p:sp>
         <p:nvSpPr>
-          <p:cNvPr id="35" name="Text 33"/>
+          <p:cNvPr id="38" name="Text 36"/>
           <p:cNvSpPr/>
           <p:nvPr/>
         </p:nvSpPr>
@@ -13698,7 +13796,7 @@
       </p:sp>
       <p:sp>
         <p:nvSpPr>
-          <p:cNvPr id="36" name="Shape 34"/>
+          <p:cNvPr id="39" name="Shape 37"/>
           <p:cNvSpPr/>
           <p:nvPr/>
         </p:nvSpPr>
@@ -13718,7 +13816,7 @@
       </p:sp>
       <p:sp>
         <p:nvSpPr>
-          <p:cNvPr id="37" name="Text 35"/>
+          <p:cNvPr id="40" name="Text 38"/>
           <p:cNvSpPr/>
           <p:nvPr/>
         </p:nvSpPr>
@@ -13757,7 +13855,7 @@
       </p:sp>
       <p:sp>
         <p:nvSpPr>
-          <p:cNvPr id="38" name="Text 36"/>
+          <p:cNvPr id="41" name="Text 39"/>
           <p:cNvSpPr/>
           <p:nvPr/>
         </p:nvSpPr>
@@ -13796,7 +13894,7 @@
       </p:sp>
       <p:sp>
         <p:nvSpPr>
-          <p:cNvPr id="39" name="Shape 37"/>
+          <p:cNvPr id="42" name="Shape 40"/>
           <p:cNvSpPr/>
           <p:nvPr/>
         </p:nvSpPr>
@@ -13816,7 +13914,7 @@
       </p:sp>
       <p:sp>
         <p:nvSpPr>
-          <p:cNvPr id="40" name="Text 38"/>
+          <p:cNvPr id="43" name="Text 41"/>
           <p:cNvSpPr/>
           <p:nvPr/>
         </p:nvSpPr>
@@ -13855,7 +13953,7 @@
       </p:sp>
       <p:sp>
         <p:nvSpPr>
-          <p:cNvPr id="41" name="Text 39"/>
+          <p:cNvPr id="44" name="Text 42"/>
           <p:cNvSpPr/>
           <p:nvPr/>
         </p:nvSpPr>
@@ -13894,7 +13992,7 @@
       </p:sp>
       <p:sp>
         <p:nvSpPr>
-          <p:cNvPr id="42" name="Shape 40"/>
+          <p:cNvPr id="45" name="Shape 43"/>
           <p:cNvSpPr/>
           <p:nvPr/>
         </p:nvSpPr>
@@ -13921,7 +14019,7 @@
       </p:sp>
       <p:sp>
         <p:nvSpPr>
-          <p:cNvPr id="43" name="Text 41"/>
+          <p:cNvPr id="46" name="Text 44"/>
           <p:cNvSpPr/>
           <p:nvPr/>
         </p:nvSpPr>
@@ -13960,30 +14058,30 @@
       </p:sp>
       <p:sp>
         <p:nvSpPr>
-          <p:cNvPr id="44" name="Text 42"/>
-          <p:cNvSpPr/>
-          <p:nvPr/>
-        </p:nvSpPr>
-        <p:spPr>
-          <a:xfrm>
-            <a:off x="914400" y="4709160"/>
-            <a:ext cx="4846320" cy="457200"/>
-          </a:xfrm>
-          <a:prstGeom prst="rect">
-            <a:avLst/>
-          </a:prstGeom>
-          <a:noFill/>
-          <a:ln/>
-        </p:spPr>
-        <p:txBody>
-          <a:bodyPr wrap="square" lIns="0" tIns="0" rIns="0" bIns="0" rtlCol="0" anchor="ctr"/>
-          <a:lstStyle/>
-          <a:p>
-            <a:pPr indent="0" marL="0">
-              <a:buNone/>
-            </a:pPr>
-            <a:r>
-              <a:rPr lang="en-US" sz="1300" b="1" dirty="0">
+          <p:cNvPr id="47" name="Text 45"/>
+          <p:cNvSpPr/>
+          <p:nvPr/>
+        </p:nvSpPr>
+        <p:spPr>
+          <a:xfrm>
+            <a:off x="914400" y="4663440"/>
+            <a:ext cx="4846320" cy="548640"/>
+          </a:xfrm>
+          <a:prstGeom prst="rect">
+            <a:avLst/>
+          </a:prstGeom>
+          <a:noFill/>
+          <a:ln/>
+        </p:spPr>
+        <p:txBody>
+          <a:bodyPr wrap="square" lIns="0" tIns="0" rIns="0" bIns="0" rtlCol="0" anchor="ctr"/>
+          <a:lstStyle/>
+          <a:p>
+            <a:pPr indent="0" marL="0">
+              <a:buNone/>
+            </a:pPr>
+            <a:r>
+              <a:rPr lang="en-US" sz="1250" b="1" dirty="0">
                 <a:solidFill>
                   <a:srgbClr val="111827"/>
                 </a:solidFill>
@@ -13991,13 +14089,13 @@
                 <a:ea typeface="Calibri" pitchFamily="34" charset="-122"/>
                 <a:cs typeface="Calibri" pitchFamily="34" charset="-120"/>
               </a:rPr>
-              <a:t>WA V0 pilot</a:t>
-            </a:r>
-            <a:pPr indent="0" marL="0">
-              <a:buNone/>
-            </a:pPr>
-            <a:r>
-              <a:rPr lang="en-US" sz="1300" dirty="0">
+              <a:t>WA V0</a:t>
+            </a:r>
+            <a:pPr indent="0" marL="0">
+              <a:buNone/>
+            </a:pPr>
+            <a:r>
+              <a:rPr lang="en-US" sz="1250" dirty="0">
                 <a:solidFill>
                   <a:srgbClr val="111827"/>
                 </a:solidFill>
@@ -14011,7 +14109,7 @@
               <a:buNone/>
             </a:pPr>
             <a:r>
-              <a:rPr lang="en-US" sz="1300" b="1" dirty="0">
+              <a:rPr lang="en-US" sz="1250" b="1" dirty="0">
                 <a:solidFill>
                   <a:srgbClr val="111827"/>
                 </a:solidFill>
@@ -14019,13 +14117,13 @@
                 <a:ea typeface="Calibri" pitchFamily="34" charset="-122"/>
                 <a:cs typeface="Calibri" pitchFamily="34" charset="-120"/>
               </a:rPr>
-              <a:t>WA Full + OTP</a:t>
-            </a:r>
-            <a:pPr indent="0" marL="0">
-              <a:buNone/>
-            </a:pPr>
-            <a:r>
-              <a:rPr lang="en-US" sz="1300" dirty="0">
+              <a:t>WA V1</a:t>
+            </a:r>
+            <a:pPr indent="0" marL="0">
+              <a:buNone/>
+            </a:pPr>
+            <a:r>
+              <a:rPr lang="en-US" sz="1250" dirty="0">
                 <a:solidFill>
                   <a:srgbClr val="111827"/>
                 </a:solidFill>
@@ -14039,7 +14137,7 @@
               <a:buNone/>
             </a:pPr>
             <a:r>
-              <a:rPr lang="en-US" sz="1300" b="1" dirty="0">
+              <a:rPr lang="en-US" sz="1250" b="1" dirty="0">
                 <a:solidFill>
                   <a:srgbClr val="111827"/>
                 </a:solidFill>
@@ -14047,13 +14145,41 @@
                 <a:ea typeface="Calibri" pitchFamily="34" charset="-122"/>
                 <a:cs typeface="Calibri" pitchFamily="34" charset="-120"/>
               </a:rPr>
+              <a:t>WA V2</a:t>
+            </a:r>
+            <a:pPr indent="0" marL="0">
+              <a:buNone/>
+            </a:pPr>
+            <a:r>
+              <a:rPr lang="en-US" sz="1250" dirty="0">
+                <a:solidFill>
+                  <a:srgbClr val="111827"/>
+                </a:solidFill>
+                <a:latin typeface="Calibri" pitchFamily="34" charset="0"/>
+                <a:ea typeface="Calibri" pitchFamily="34" charset="-122"/>
+                <a:cs typeface="Calibri" pitchFamily="34" charset="-120"/>
+              </a:rPr>
+              <a:t> (Feb)  ·  </a:t>
+            </a:r>
+            <a:pPr indent="0" marL="0">
+              <a:buNone/>
+            </a:pPr>
+            <a:r>
+              <a:rPr lang="en-US" sz="1250" b="1" dirty="0">
+                <a:solidFill>
+                  <a:srgbClr val="111827"/>
+                </a:solidFill>
+                <a:latin typeface="Calibri" pitchFamily="34" charset="0"/>
+                <a:ea typeface="Calibri" pitchFamily="34" charset="-122"/>
+                <a:cs typeface="Calibri" pitchFamily="34" charset="-120"/>
+              </a:rPr>
               <a:t>Mobile App</a:t>
             </a:r>
             <a:pPr indent="0" marL="0">
               <a:buNone/>
             </a:pPr>
             <a:r>
-              <a:rPr lang="en-US" sz="1300" dirty="0">
+              <a:rPr lang="en-US" sz="1250" dirty="0">
                 <a:solidFill>
                   <a:srgbClr val="111827"/>
                 </a:solidFill>
@@ -14063,20 +14189,20 @@
               </a:rPr>
               <a:t> (Mar)</a:t>
             </a:r>
-            <a:endParaRPr lang="en-US" sz="1300" dirty="0"/>
-          </a:p>
-        </p:txBody>
-      </p:sp>
-      <p:sp>
-        <p:nvSpPr>
-          <p:cNvPr id="45" name="Text 43"/>
+            <a:endParaRPr lang="en-US" sz="1250" dirty="0"/>
+          </a:p>
+        </p:txBody>
+      </p:sp>
+      <p:sp>
+        <p:nvSpPr>
+          <p:cNvPr id="48" name="Text 46"/>
           <p:cNvSpPr/>
           <p:nvPr/>
         </p:nvSpPr>
         <p:spPr>
           <a:xfrm>
             <a:off x="914400" y="5257800"/>
-            <a:ext cx="4846320" cy="548640"/>
+            <a:ext cx="4846320" cy="502920"/>
           </a:xfrm>
           <a:prstGeom prst="rect">
             <a:avLst/>
@@ -14100,7 +14226,7 @@
                 <a:ea typeface="Calibri" pitchFamily="34" charset="-122"/>
                 <a:cs typeface="Calibri" pitchFamily="34" charset="-120"/>
               </a:rPr>
-              <a:t>The App - Bullet's priority - lands just inside the deadline.</a:t>
+              <a:t>V0-V2: WhatsApp pilot through complete. App - Bullet's priority - lands just inside the deadline.</a:t>
             </a:r>
             <a:endParaRPr lang="en-US" sz="1150" dirty="0"/>
           </a:p>
@@ -14108,7 +14234,7 @@
       </p:sp>
       <p:sp>
         <p:nvSpPr>
-          <p:cNvPr id="46" name="Shape 44"/>
+          <p:cNvPr id="49" name="Shape 47"/>
           <p:cNvSpPr/>
           <p:nvPr/>
         </p:nvSpPr>
@@ -14135,7 +14261,7 @@
       </p:sp>
       <p:sp>
         <p:nvSpPr>
-          <p:cNvPr id="47" name="Text 45"/>
+          <p:cNvPr id="50" name="Text 48"/>
           <p:cNvSpPr/>
           <p:nvPr/>
         </p:nvSpPr>
@@ -14174,7 +14300,7 @@
       </p:sp>
       <p:sp>
         <p:nvSpPr>
-          <p:cNvPr id="48" name="Text 46"/>
+          <p:cNvPr id="51" name="Text 49"/>
           <p:cNvSpPr/>
           <p:nvPr/>
         </p:nvSpPr>
@@ -14255,7 +14381,7 @@
       </p:sp>
       <p:sp>
         <p:nvSpPr>
-          <p:cNvPr id="49" name="Text 47"/>
+          <p:cNvPr id="52" name="Text 50"/>
           <p:cNvSpPr/>
           <p:nvPr/>
         </p:nvSpPr>
@@ -14294,7 +14420,7 @@
       </p:sp>
       <p:sp>
         <p:nvSpPr>
-          <p:cNvPr id="50" name="Text 48"/>
+          <p:cNvPr id="53" name="Text 51"/>
           <p:cNvSpPr/>
           <p:nvPr/>
         </p:nvSpPr>
@@ -14361,7 +14487,7 @@
       </p:sp>
       <p:sp>
         <p:nvSpPr>
-          <p:cNvPr id="51" name="Text 49"/>
+          <p:cNvPr id="54" name="Text 52"/>
           <p:cNvSpPr/>
           <p:nvPr/>
         </p:nvSpPr>

</xml_diff>

<commit_message>
PPTX alignment pass: V0 terminology, four weeks, Pilot tag
- Slide 1: 'WhatsApp MVP' → 'WhatsApp V0' in meta strip
- Slide 5: WhatsApp chip tag 'MVP' → 'Pilot'
- Slide 12: 'First three weeks' → 'First four weeks' in agenda

Co-Authored-By: Claude Sonnet 4.6 <noreply@anthropic.com>
</commit_message>
<xml_diff>
--- a/Notch-Bullet-Kickoff.pptx
+++ b/Notch-Bullet-Kickoff.pptx
@@ -2258,7 +2258,7 @@
                 <a:ea typeface="Calibri" pitchFamily="34" charset="-122"/>
                 <a:cs typeface="Calibri" pitchFamily="34" charset="-120"/>
               </a:rPr>
-              <a:t>WhatsApp MVP</a:t>
+              <a:t>WhatsApp V0</a:t>
             </a:r>
             <a:endParaRPr lang="en-US" sz="1250" dirty="0"/>
           </a:p>
@@ -6720,7 +6720,7 @@
                 <a:ea typeface="Calibri" pitchFamily="34" charset="-122"/>
                 <a:cs typeface="Calibri" pitchFamily="34" charset="-120"/>
               </a:rPr>
-              <a:t>First three weeks &amp; owners</a:t>
+              <a:t>First four weeks &amp; owners</a:t>
             </a:r>
             <a:endParaRPr lang="en-US" sz="1250" dirty="0"/>
           </a:p>
@@ -11503,8 +11503,8 @@
         </p:nvSpPr>
         <p:spPr>
           <a:xfrm>
-            <a:off x="1725930" y="3749040"/>
-            <a:ext cx="434340" cy="274320"/>
+            <a:off x="1648206" y="3749040"/>
+            <a:ext cx="589788" cy="274320"/>
           </a:xfrm>
           <a:prstGeom prst="roundRect">
             <a:avLst>
@@ -11525,8 +11525,8 @@
         </p:nvSpPr>
         <p:spPr>
           <a:xfrm>
-            <a:off x="1725930" y="3749040"/>
-            <a:ext cx="434340" cy="274320"/>
+            <a:off x="1648206" y="3749040"/>
+            <a:ext cx="589788" cy="274320"/>
           </a:xfrm>
           <a:prstGeom prst="rect">
             <a:avLst/>
@@ -11550,7 +11550,7 @@
                 <a:ea typeface="Calibri" pitchFamily="34" charset="-122"/>
                 <a:cs typeface="Calibri" pitchFamily="34" charset="-120"/>
               </a:rPr>
-              <a:t>MVP</a:t>
+              <a:t>Pilot</a:t>
             </a:r>
             <a:endParaRPr lang="en-US" sz="950" dirty="0"/>
           </a:p>

</xml_diff>